<commit_message>
Add day 12 materials
</commit_message>
<xml_diff>
--- a/заняття_12/Python_files.pptx
+++ b/заняття_12/Python_files.pptx
@@ -4,6 +4,9 @@
   <p:sldMasterIdLst>
     <p:sldMasterId id="2147483648" r:id="rId1"/>
   </p:sldMasterIdLst>
+  <p:notesMasterIdLst>
+    <p:notesMasterId r:id="rId11"/>
+  </p:notesMasterIdLst>
   <p:sldIdLst>
     <p:sldId id="256" r:id="rId2"/>
     <p:sldId id="257" r:id="rId3"/>
@@ -15,9 +18,6 @@
     <p:sldId id="263" r:id="rId9"/>
     <p:sldId id="264" r:id="rId10"/>
   </p:sldIdLst>
-  <p:notesMasterIdLst>
-    <p:notesMasterId r:id="rId11"/>
-  </p:notesMasterIdLst>
   <p:sldSz cx="12192000" cy="6858000"/>
   <p:notesSz cx="6858000" cy="12192000"/>
   <p:defaultTextStyle>
@@ -112,6 +112,11 @@
       </a:defRPr>
     </a:lvl9pPr>
   </p:defaultTextStyle>
+  <p:extLst>
+    <p:ext uri="{EFAFB233-063F-42B5-8137-9DF3F51BA10A}">
+      <p15:sldGuideLst xmlns:p15="http://schemas.microsoft.com/office/powerpoint/2012/main"/>
+    </p:ext>
+  </p:extLst>
 </p:presentation>
 </file>
 
@@ -137,234 +142,10 @@
           <a:chExt cx="0" cy="0"/>
         </a:xfrm>
       </p:grpSpPr>
-      <p:sp>
-        <p:nvSpPr>
-          <p:cNvPr id="2" name="Header Placeholder 1"/>
-          <p:cNvSpPr>
-            <a:spLocks noGrp="1"/>
-          </p:cNvSpPr>
-          <p:nvPr>
-            <p:ph type="hdr" sz="quarter"/>
-          </p:nvPr>
-        </p:nvSpPr>
-        <p:spPr>
-          <a:xfrm>
-            <a:off x="0" y="0"/>
-            <a:ext cx="2971800" cy="458788"/>
-          </a:xfrm>
-          <a:prstGeom prst="rect">
-            <a:avLst/>
-          </a:prstGeom>
-        </p:spPr>
-        <p:txBody>
-          <a:bodyPr vert="horz" lIns="91440" tIns="45720" rIns="91440" bIns="45720" rtlCol="0"/>
-          <a:lstStyle>
-            <a:lvl1pPr algn="l">
-              <a:defRPr sz="1200"/>
-            </a:lvl1pPr>
-          </a:lstStyle>
-          <a:p>
-            <a:endParaRPr lang="en-US"/>
-          </a:p>
-        </p:txBody>
-      </p:sp>
-      <p:sp>
-        <p:nvSpPr>
-          <p:cNvPr id="3" name="Date Placeholder 2"/>
-          <p:cNvSpPr>
-            <a:spLocks noGrp="1"/>
-          </p:cNvSpPr>
-          <p:nvPr>
-            <p:ph type="dt" idx="1"/>
-          </p:nvPr>
-        </p:nvSpPr>
-        <p:spPr>
-          <a:xfrm>
-            <a:off x="3884613" y="0"/>
-            <a:ext cx="2971800" cy="458788"/>
-          </a:xfrm>
-          <a:prstGeom prst="rect">
-            <a:avLst/>
-          </a:prstGeom>
-        </p:spPr>
-        <p:txBody>
-          <a:bodyPr vert="horz" lIns="91440" tIns="45720" rIns="91440" bIns="45720" rtlCol="0"/>
-          <a:lstStyle>
-            <a:lvl1pPr algn="r">
-              <a:defRPr sz="1200"/>
-            </a:lvl1pPr>
-          </a:lstStyle>
-          <a:p>
-            <a:fld id="{5282F153-3F37-0F45-9E97-73ACFA13230C}" type="datetimeFigureOut">
-              <a:rPr lang="en-US"/>
-              <a:t>7/23/19</a:t>
-            </a:fld>
-            <a:endParaRPr lang="en-US"/>
-          </a:p>
-        </p:txBody>
-      </p:sp>
-      <p:sp>
-        <p:nvSpPr>
-          <p:cNvPr id="4" name="Slide Image Placeholder 3"/>
-          <p:cNvSpPr>
-            <a:spLocks noGrp="1" noRot="1" noChangeAspect="1"/>
-          </p:cNvSpPr>
-          <p:nvPr>
-            <p:ph type="sldImg" idx="2"/>
-          </p:nvPr>
-        </p:nvSpPr>
-        <p:spPr>
-          <a:xfrm>
-            <a:off x="685800" y="1143000"/>
-            <a:ext cx="5486400" cy="3086100"/>
-          </a:xfrm>
-          <a:prstGeom prst="rect">
-            <a:avLst/>
-          </a:prstGeom>
-          <a:noFill/>
-          <a:ln w="12700">
-            <a:solidFill>
-              <a:prstClr val="black"/>
-            </a:solidFill>
-          </a:ln>
-        </p:spPr>
-        <p:txBody>
-          <a:bodyPr vert="horz" lIns="91440" tIns="45720" rIns="91440" bIns="45720" rtlCol="0" anchor="ctr"/>
-          <a:lstStyle/>
-          <a:p>
-            <a:endParaRPr lang="en-US"/>
-          </a:p>
-        </p:txBody>
-      </p:sp>
-      <p:sp>
-        <p:nvSpPr>
-          <p:cNvPr id="5" name="Notes Placeholder 4"/>
-          <p:cNvSpPr>
-            <a:spLocks noGrp="1"/>
-          </p:cNvSpPr>
-          <p:nvPr>
-            <p:ph type="body" sz="quarter" idx="3"/>
-          </p:nvPr>
-        </p:nvSpPr>
-        <p:spPr>
-          <a:xfrm>
-            <a:off x="685800" y="4400550"/>
-            <a:ext cx="5486400" cy="3600450"/>
-          </a:xfrm>
-          <a:prstGeom prst="rect">
-            <a:avLst/>
-          </a:prstGeom>
-        </p:spPr>
-        <p:txBody>
-          <a:bodyPr vert="horz" lIns="91440" tIns="45720" rIns="91440" bIns="45720" rtlCol="0"/>
-          <a:lstStyle/>
-          <a:p>
-            <a:pPr lvl="0"/>
-            <a:r>
-              <a:rPr lang="en-US"/>
-              <a:t>Click to edit Master text styles</a:t>
-            </a:r>
-          </a:p>
-          <a:p>
-            <a:pPr lvl="1"/>
-            <a:r>
-              <a:rPr lang="en-US"/>
-              <a:t>Second level</a:t>
-            </a:r>
-          </a:p>
-          <a:p>
-            <a:pPr lvl="2"/>
-            <a:r>
-              <a:rPr lang="en-US"/>
-              <a:t>Third level</a:t>
-            </a:r>
-          </a:p>
-          <a:p>
-            <a:pPr lvl="3"/>
-            <a:r>
-              <a:rPr lang="en-US"/>
-              <a:t>Fourth level</a:t>
-            </a:r>
-          </a:p>
-          <a:p>
-            <a:pPr lvl="4"/>
-            <a:r>
-              <a:rPr lang="en-US"/>
-              <a:t>Fifth level</a:t>
-            </a:r>
-          </a:p>
-        </p:txBody>
-      </p:sp>
-      <p:sp>
-        <p:nvSpPr>
-          <p:cNvPr id="6" name="Footer Placeholder 5"/>
-          <p:cNvSpPr>
-            <a:spLocks noGrp="1"/>
-          </p:cNvSpPr>
-          <p:nvPr>
-            <p:ph type="ftr" sz="quarter" idx="4"/>
-          </p:nvPr>
-        </p:nvSpPr>
-        <p:spPr>
-          <a:xfrm>
-            <a:off x="0" y="8685213"/>
-            <a:ext cx="2971800" cy="458787"/>
-          </a:xfrm>
-          <a:prstGeom prst="rect">
-            <a:avLst/>
-          </a:prstGeom>
-        </p:spPr>
-        <p:txBody>
-          <a:bodyPr vert="horz" lIns="91440" tIns="45720" rIns="91440" bIns="45720" rtlCol="0" anchor="b"/>
-          <a:lstStyle>
-            <a:lvl1pPr algn="l">
-              <a:defRPr sz="1200"/>
-            </a:lvl1pPr>
-          </a:lstStyle>
-          <a:p>
-            <a:endParaRPr lang="en-US"/>
-          </a:p>
-        </p:txBody>
-      </p:sp>
-      <p:sp>
-        <p:nvSpPr>
-          <p:cNvPr id="7" name="Slide Number Placeholder 6"/>
-          <p:cNvSpPr>
-            <a:spLocks noGrp="1"/>
-          </p:cNvSpPr>
-          <p:nvPr>
-            <p:ph type="sldNum" sz="quarter" idx="5"/>
-          </p:nvPr>
-        </p:nvSpPr>
-        <p:spPr>
-          <a:xfrm>
-            <a:off x="3884613" y="8685213"/>
-            <a:ext cx="2971800" cy="458787"/>
-          </a:xfrm>
-          <a:prstGeom prst="rect">
-            <a:avLst/>
-          </a:prstGeom>
-        </p:spPr>
-        <p:txBody>
-          <a:bodyPr vert="horz" lIns="91440" tIns="45720" rIns="91440" bIns="45720" rtlCol="0" anchor="b"/>
-          <a:lstStyle>
-            <a:lvl1pPr algn="r">
-              <a:defRPr sz="1200"/>
-            </a:lvl1pPr>
-          </a:lstStyle>
-          <a:p>
-            <a:fld id="{CE5E9CC1-C706-0F49-92D6-E571CC5EEA8F}" type="slidenum">
-              <a:rPr lang="en-US"/>
-              <a:t>‹#›</a:t>
-            </a:fld>
-            <a:endParaRPr lang="en-US"/>
-          </a:p>
-        </p:txBody>
-      </p:sp>
     </p:spTree>
     <p:extLst>
       <p:ext uri="{BB962C8B-B14F-4D97-AF65-F5344CB8AC3E}">
-        <p14:creationId xmlns:p14="http://schemas.microsoft.com/office/powerpoint/2010/main" val="1024086991"/>
+        <p14:creationId xmlns:p14="http://schemas.microsoft.com/office/powerpoint/2010/main" val="3499024039"/>
       </p:ext>
     </p:extLst>
   </p:cSld>
@@ -492,6 +273,13 @@
           </p:nvPr>
         </p:nvSpPr>
         <p:spPr/>
+        <p:txBody>
+          <a:bodyPr/>
+          <a:lstStyle/>
+          <a:p>
+            <a:endParaRPr lang="en-UA"/>
+          </a:p>
+        </p:txBody>
       </p:sp>
       <p:sp>
         <p:nvSpPr>
@@ -508,10 +296,6 @@
           <a:bodyPr/>
           <a:lstStyle/>
           <a:p>
-            <a:r>
-              <a:rPr lang="en-US" dirty="0"/>
-              <a:t/>
-            </a:r>
             <a:endParaRPr lang="en-US" dirty="0"/>
           </a:p>
         </p:txBody>
@@ -580,6 +364,13 @@
           </p:nvPr>
         </p:nvSpPr>
         <p:spPr/>
+        <p:txBody>
+          <a:bodyPr/>
+          <a:lstStyle/>
+          <a:p>
+            <a:endParaRPr lang="en-UA"/>
+          </a:p>
+        </p:txBody>
       </p:sp>
       <p:sp>
         <p:nvSpPr>
@@ -596,10 +387,6 @@
           <a:bodyPr/>
           <a:lstStyle/>
           <a:p>
-            <a:r>
-              <a:rPr lang="en-US" dirty="0"/>
-              <a:t/>
-            </a:r>
             <a:endParaRPr lang="en-US" dirty="0"/>
           </a:p>
         </p:txBody>
@@ -668,6 +455,13 @@
           </p:nvPr>
         </p:nvSpPr>
         <p:spPr/>
+        <p:txBody>
+          <a:bodyPr/>
+          <a:lstStyle/>
+          <a:p>
+            <a:endParaRPr lang="en-UA"/>
+          </a:p>
+        </p:txBody>
       </p:sp>
       <p:sp>
         <p:nvSpPr>
@@ -684,10 +478,6 @@
           <a:bodyPr/>
           <a:lstStyle/>
           <a:p>
-            <a:r>
-              <a:rPr lang="en-US" dirty="0"/>
-              <a:t/>
-            </a:r>
             <a:endParaRPr lang="en-US" dirty="0"/>
           </a:p>
         </p:txBody>
@@ -756,6 +546,13 @@
           </p:nvPr>
         </p:nvSpPr>
         <p:spPr/>
+        <p:txBody>
+          <a:bodyPr/>
+          <a:lstStyle/>
+          <a:p>
+            <a:endParaRPr lang="en-UA"/>
+          </a:p>
+        </p:txBody>
       </p:sp>
       <p:sp>
         <p:nvSpPr>
@@ -772,10 +569,6 @@
           <a:bodyPr/>
           <a:lstStyle/>
           <a:p>
-            <a:r>
-              <a:rPr lang="en-US" dirty="0"/>
-              <a:t/>
-            </a:r>
             <a:endParaRPr lang="en-US" dirty="0"/>
           </a:p>
         </p:txBody>
@@ -844,6 +637,13 @@
           </p:nvPr>
         </p:nvSpPr>
         <p:spPr/>
+        <p:txBody>
+          <a:bodyPr/>
+          <a:lstStyle/>
+          <a:p>
+            <a:endParaRPr lang="en-UA"/>
+          </a:p>
+        </p:txBody>
       </p:sp>
       <p:sp>
         <p:nvSpPr>
@@ -860,10 +660,6 @@
           <a:bodyPr/>
           <a:lstStyle/>
           <a:p>
-            <a:r>
-              <a:rPr lang="en-US" dirty="0"/>
-              <a:t/>
-            </a:r>
             <a:endParaRPr lang="en-US" dirty="0"/>
           </a:p>
         </p:txBody>
@@ -932,6 +728,13 @@
           </p:nvPr>
         </p:nvSpPr>
         <p:spPr/>
+        <p:txBody>
+          <a:bodyPr/>
+          <a:lstStyle/>
+          <a:p>
+            <a:endParaRPr lang="en-UA"/>
+          </a:p>
+        </p:txBody>
       </p:sp>
       <p:sp>
         <p:nvSpPr>
@@ -948,10 +751,6 @@
           <a:bodyPr/>
           <a:lstStyle/>
           <a:p>
-            <a:r>
-              <a:rPr lang="en-US" dirty="0"/>
-              <a:t/>
-            </a:r>
             <a:endParaRPr lang="en-US" dirty="0"/>
           </a:p>
         </p:txBody>
@@ -1020,6 +819,13 @@
           </p:nvPr>
         </p:nvSpPr>
         <p:spPr/>
+        <p:txBody>
+          <a:bodyPr/>
+          <a:lstStyle/>
+          <a:p>
+            <a:endParaRPr lang="en-UA"/>
+          </a:p>
+        </p:txBody>
       </p:sp>
       <p:sp>
         <p:nvSpPr>
@@ -1036,10 +842,6 @@
           <a:bodyPr/>
           <a:lstStyle/>
           <a:p>
-            <a:r>
-              <a:rPr lang="en-US" dirty="0"/>
-              <a:t/>
-            </a:r>
             <a:endParaRPr lang="en-US" dirty="0"/>
           </a:p>
         </p:txBody>
@@ -1108,6 +910,13 @@
           </p:nvPr>
         </p:nvSpPr>
         <p:spPr/>
+        <p:txBody>
+          <a:bodyPr/>
+          <a:lstStyle/>
+          <a:p>
+            <a:endParaRPr lang="en-UA"/>
+          </a:p>
+        </p:txBody>
       </p:sp>
       <p:sp>
         <p:nvSpPr>
@@ -1124,10 +933,6 @@
           <a:bodyPr/>
           <a:lstStyle/>
           <a:p>
-            <a:r>
-              <a:rPr lang="en-US" dirty="0"/>
-              <a:t/>
-            </a:r>
             <a:endParaRPr lang="en-US" dirty="0"/>
           </a:p>
         </p:txBody>
@@ -1196,6 +1001,13 @@
           </p:nvPr>
         </p:nvSpPr>
         <p:spPr/>
+        <p:txBody>
+          <a:bodyPr/>
+          <a:lstStyle/>
+          <a:p>
+            <a:endParaRPr lang="en-UA"/>
+          </a:p>
+        </p:txBody>
       </p:sp>
       <p:sp>
         <p:nvSpPr>
@@ -1212,10 +1024,6 @@
           <a:bodyPr/>
           <a:lstStyle/>
           <a:p>
-            <a:r>
-              <a:rPr lang="en-US" dirty="0"/>
-              <a:t/>
-            </a:r>
             <a:endParaRPr lang="en-US" dirty="0"/>
           </a:p>
         </p:txBody>
@@ -1289,6 +1097,11 @@
 <file path=ppt/slideMasters/slideMaster1.xml><?xml version="1.0" encoding="utf-8"?>
 <p:sldMaster xmlns:a="http://schemas.openxmlformats.org/drawingml/2006/main" xmlns:r="http://schemas.openxmlformats.org/officeDocument/2006/relationships" xmlns:p="http://schemas.openxmlformats.org/presentationml/2006/main">
   <p:cSld>
+    <p:bg>
+      <p:bgRef idx="1001">
+        <a:schemeClr val="bg1"/>
+      </p:bgRef>
+    </p:bg>
     <p:spTree>
       <p:nvGrpSpPr>
         <p:cNvPr id="1" name=""/>
@@ -1571,6 +1384,7 @@
         <a:solidFill>
           <a:srgbClr val="0B1E33"/>
         </a:solidFill>
+        <a:effectLst/>
       </p:bgPr>
     </p:bg>
     <p:spTree>
@@ -1606,17 +1420,24 @@
           </a:solidFill>
           <a:ln/>
         </p:spPr>
+        <p:txBody>
+          <a:bodyPr/>
+          <a:lstStyle/>
+          <a:p>
+            <a:endParaRPr lang="en-UA"/>
+          </a:p>
+        </p:txBody>
       </p:sp>
       <p:pic>
         <p:nvPicPr>
-          <p:cNvPr id="3" name="Image 0" descr="preencoded.png">    </p:cNvPr>
+          <p:cNvPr id="3" name="Image 0" descr="preencoded.png"/>
           <p:cNvPicPr>
             <a:picLocks noChangeAspect="1"/>
           </p:cNvPicPr>
           <p:nvPr/>
         </p:nvPicPr>
         <p:blipFill>
-          <a:blip r:embed="rId1"/>
+          <a:blip r:embed="rId3"/>
           <a:stretch>
             <a:fillRect/>
           </a:stretch>
@@ -1650,17 +1471,24 @@
           </a:solidFill>
           <a:ln/>
         </p:spPr>
+        <p:txBody>
+          <a:bodyPr/>
+          <a:lstStyle/>
+          <a:p>
+            <a:endParaRPr lang="en-UA"/>
+          </a:p>
+        </p:txBody>
       </p:sp>
       <p:pic>
         <p:nvPicPr>
-          <p:cNvPr id="5" name="Image 1" descr="preencoded.png">    </p:cNvPr>
+          <p:cNvPr id="5" name="Image 1" descr="preencoded.png"/>
           <p:cNvPicPr>
             <a:picLocks noChangeAspect="1"/>
           </p:cNvPicPr>
           <p:nvPr/>
         </p:nvPicPr>
         <p:blipFill>
-          <a:blip r:embed="rId2"/>
+          <a:blip r:embed="rId4"/>
           <a:stretch>
             <a:fillRect/>
           </a:stretch>
@@ -1696,11 +1524,11 @@
           <a:bodyPr wrap="square" lIns="0" tIns="0" rIns="0" bIns="0" rtlCol="0" anchor="ctr"/>
           <a:lstStyle/>
           <a:p>
-            <a:pPr indent="0" marL="0">
-              <a:buNone/>
-            </a:pPr>
-            <a:r>
-              <a:rPr lang="en-US" sz="1800" b="1" spc="400" kern="0" dirty="0">
+            <a:pPr marL="0" indent="0">
+              <a:buNone/>
+            </a:pPr>
+            <a:r>
+              <a:rPr lang="en-US" sz="1800" b="1" kern="0" spc="400" dirty="0">
                 <a:solidFill>
                   <a:srgbClr val="5FD0C2"/>
                 </a:solidFill>
@@ -1735,7 +1563,7 @@
           <a:bodyPr wrap="square" lIns="0" tIns="0" rIns="0" bIns="0" rtlCol="0" anchor="ctr"/>
           <a:lstStyle/>
           <a:p>
-            <a:pPr indent="0" marL="0">
+            <a:pPr marL="0" indent="0">
               <a:buNone/>
             </a:pPr>
             <a:r>
@@ -1774,7 +1602,7 @@
           <a:bodyPr wrap="square" lIns="0" tIns="0" rIns="0" bIns="0" rtlCol="0" anchor="ctr"/>
           <a:lstStyle/>
           <a:p>
-            <a:pPr indent="0" marL="0">
+            <a:pPr marL="0" indent="0">
               <a:buNone/>
             </a:pPr>
             <a:r>
@@ -1814,6 +1642,13 @@
             <a:prstDash val="solid"/>
           </a:ln>
         </p:spPr>
+        <p:txBody>
+          <a:bodyPr/>
+          <a:lstStyle/>
+          <a:p>
+            <a:endParaRPr lang="en-UA"/>
+          </a:p>
+        </p:txBody>
       </p:sp>
       <p:sp>
         <p:nvSpPr>
@@ -1836,11 +1671,8 @@
           <a:bodyPr wrap="square" lIns="0" tIns="0" rIns="0" bIns="0" rtlCol="0" anchor="ctr"/>
           <a:lstStyle/>
           <a:p>
-            <a:pPr indent="0" marL="0">
-              <a:buNone/>
-            </a:pPr>
-            <a:r>
-              <a:rPr lang="en-US" sz="1200" dirty="0">
+            <a:r>
+              <a:rPr lang="ru-RU" sz="1200" dirty="0">
                 <a:solidFill>
                   <a:srgbClr val="6F8C94"/>
                 </a:solidFill>
@@ -1848,7 +1680,40 @@
                 <a:ea typeface="Calibri" pitchFamily="34" charset="-122"/>
                 <a:cs typeface="Calibri" pitchFamily="34" charset="-120"/>
               </a:rPr>
-              <a:t>Курс з Python та веб-розробки</a:t>
+              <a:t>Створення </a:t>
+            </a:r>
+            <a:r>
+              <a:rPr lang="en-US" sz="1200" dirty="0">
+                <a:solidFill>
+                  <a:srgbClr val="6F8C94"/>
+                </a:solidFill>
+                <a:latin typeface="Calibri" pitchFamily="34" charset="0"/>
+                <a:ea typeface="Calibri" pitchFamily="34" charset="-122"/>
+                <a:cs typeface="Calibri" pitchFamily="34" charset="-120"/>
+              </a:rPr>
+              <a:t>web-</a:t>
+            </a:r>
+            <a:r>
+              <a:rPr lang="ru-RU" sz="1200" dirty="0">
+                <a:solidFill>
+                  <a:srgbClr val="6F8C94"/>
+                </a:solidFill>
+                <a:latin typeface="Calibri" pitchFamily="34" charset="0"/>
+                <a:ea typeface="Calibri" pitchFamily="34" charset="-122"/>
+                <a:cs typeface="Calibri" pitchFamily="34" charset="-120"/>
+              </a:rPr>
+              <a:t>додатків з використанням </a:t>
+            </a:r>
+            <a:r>
+              <a:rPr lang="en-US" sz="1200" dirty="0">
+                <a:solidFill>
+                  <a:srgbClr val="6F8C94"/>
+                </a:solidFill>
+                <a:latin typeface="Calibri" pitchFamily="34" charset="0"/>
+                <a:ea typeface="Calibri" pitchFamily="34" charset="-122"/>
+                <a:cs typeface="Calibri" pitchFamily="34" charset="-120"/>
+              </a:rPr>
+              <a:t>Python</a:t>
             </a:r>
             <a:endParaRPr lang="en-US" sz="1200" dirty="0"/>
           </a:p>
@@ -1870,6 +1735,7 @@
         <a:solidFill>
           <a:srgbClr val="EAF4F6"/>
         </a:solidFill>
+        <a:effectLst/>
       </p:bgPr>
     </p:bg>
     <p:spTree>
@@ -1907,7 +1773,7 @@
           <a:bodyPr wrap="square" lIns="0" tIns="0" rIns="0" bIns="0" rtlCol="0" anchor="ctr"/>
           <a:lstStyle/>
           <a:p>
-            <a:pPr indent="0" marL="0">
+            <a:pPr marL="0" indent="0">
               <a:buNone/>
             </a:pPr>
             <a:r>
@@ -1946,7 +1812,7 @@
           <a:bodyPr wrap="square" lIns="0" tIns="0" rIns="0" bIns="0" rtlCol="0" anchor="ctr"/>
           <a:lstStyle/>
           <a:p>
-            <a:pPr indent="0" marL="0">
+            <a:pPr marL="0" indent="0">
               <a:buNone/>
             </a:pPr>
             <a:r>
@@ -1985,13 +1851,20 @@
           </a:solidFill>
           <a:ln/>
           <a:effectLst>
-            <a:outerShdw sx="100000" sy="100000" kx="0" ky="0" algn="bl" rotWithShape="0" blurRad="101600" dist="38100" dir="5400000">
+            <a:outerShdw blurRad="101600" dist="38100" dir="5400000" algn="bl" rotWithShape="0">
               <a:srgbClr val="0B1E33">
                 <a:alpha val="12000"/>
               </a:srgbClr>
             </a:outerShdw>
           </a:effectLst>
         </p:spPr>
+        <p:txBody>
+          <a:bodyPr/>
+          <a:lstStyle/>
+          <a:p>
+            <a:endParaRPr lang="en-UA"/>
+          </a:p>
+        </p:txBody>
       </p:sp>
       <p:sp>
         <p:nvSpPr>
@@ -2012,312 +1885,17 @@
           </a:solidFill>
           <a:ln/>
         </p:spPr>
+        <p:txBody>
+          <a:bodyPr/>
+          <a:lstStyle/>
+          <a:p>
+            <a:endParaRPr lang="en-UA"/>
+          </a:p>
+        </p:txBody>
       </p:sp>
       <p:pic>
         <p:nvPicPr>
-          <p:cNvPr id="6" name="Image 0" descr="preencoded.png">    </p:cNvPr>
-          <p:cNvPicPr>
-            <a:picLocks noChangeAspect="1"/>
-          </p:cNvPicPr>
-          <p:nvPr/>
-        </p:nvPicPr>
-        <p:blipFill>
-          <a:blip r:embed="rId1"/>
-          <a:stretch>
-            <a:fillRect/>
-          </a:stretch>
-        </p:blipFill>
-        <p:spPr>
-          <a:xfrm>
-            <a:off x="1662379" y="3056839"/>
-            <a:ext cx="378562" cy="378562"/>
-          </a:xfrm>
-          <a:prstGeom prst="rect">
-            <a:avLst/>
-          </a:prstGeom>
-        </p:spPr>
-      </p:pic>
-      <p:sp>
-        <p:nvSpPr>
-          <p:cNvPr id="7" name="Text 4"/>
-          <p:cNvSpPr/>
-          <p:nvPr/>
-        </p:nvSpPr>
-        <p:spPr>
-          <a:xfrm>
-            <a:off x="731520" y="3840480"/>
-            <a:ext cx="2240280" cy="548640"/>
-          </a:xfrm>
-          <a:prstGeom prst="rect">
-            <a:avLst/>
-          </a:prstGeom>
-          <a:noFill/>
-          <a:ln/>
-        </p:spPr>
-        <p:txBody>
-          <a:bodyPr wrap="square" lIns="0" tIns="0" rIns="0" bIns="0" rtlCol="0" anchor="ctr"/>
-          <a:lstStyle/>
-          <a:p>
-            <a:pPr algn="ctr" indent="0" marL="0">
-              <a:buNone/>
-            </a:pPr>
-            <a:r>
-              <a:rPr lang="en-US" sz="1500" b="1" dirty="0">
-                <a:solidFill>
-                  <a:srgbClr val="0B1E33"/>
-                </a:solidFill>
-                <a:latin typeface="Bookman Old Style" pitchFamily="34" charset="0"/>
-                <a:ea typeface="Bookman Old Style" pitchFamily="34" charset="-122"/>
-                <a:cs typeface="Bookman Old Style" pitchFamily="34" charset="-120"/>
-              </a:rPr>
-              <a:t>Збереження даних</a:t>
-            </a:r>
-            <a:endParaRPr lang="en-US" sz="1500" dirty="0"/>
-          </a:p>
-        </p:txBody>
-      </p:sp>
-      <p:sp>
-        <p:nvSpPr>
-          <p:cNvPr id="8" name="Text 5"/>
-          <p:cNvSpPr/>
-          <p:nvPr/>
-        </p:nvSpPr>
-        <p:spPr>
-          <a:xfrm>
-            <a:off x="777240" y="4343400"/>
-            <a:ext cx="2148840" cy="1097280"/>
-          </a:xfrm>
-          <a:prstGeom prst="rect">
-            <a:avLst/>
-          </a:prstGeom>
-          <a:noFill/>
-          <a:ln/>
-        </p:spPr>
-        <p:txBody>
-          <a:bodyPr wrap="square" lIns="0" tIns="0" rIns="0" bIns="0" rtlCol="0" anchor="t"/>
-          <a:lstStyle/>
-          <a:p>
-            <a:pPr algn="ctr" indent="0" marL="0">
-              <a:buNone/>
-            </a:pPr>
-            <a:r>
-              <a:rPr lang="en-US" sz="1200" dirty="0">
-                <a:solidFill>
-                  <a:srgbClr val="3A4A57"/>
-                </a:solidFill>
-                <a:latin typeface="Calibri" pitchFamily="34" charset="0"/>
-                <a:ea typeface="Calibri" pitchFamily="34" charset="-122"/>
-                <a:cs typeface="Calibri" pitchFamily="34" charset="-120"/>
-              </a:rPr>
-              <a:t>Результати роботи програми не зникають після закриття</a:t>
-            </a:r>
-            <a:endParaRPr lang="en-US" sz="1200" dirty="0"/>
-          </a:p>
-        </p:txBody>
-      </p:sp>
-      <p:sp>
-        <p:nvSpPr>
-          <p:cNvPr id="9" name="Shape 6"/>
-          <p:cNvSpPr/>
-          <p:nvPr/>
-        </p:nvSpPr>
-        <p:spPr>
-          <a:xfrm>
-            <a:off x="3474720" y="2468880"/>
-            <a:ext cx="2606040" cy="3108960"/>
-          </a:xfrm>
-          <a:prstGeom prst="roundRect">
-            <a:avLst>
-              <a:gd name="adj" fmla="val 4211"/>
-            </a:avLst>
-          </a:prstGeom>
-          <a:solidFill>
-            <a:srgbClr val="FFFFFF"/>
-          </a:solidFill>
-          <a:ln/>
-          <a:effectLst>
-            <a:outerShdw sx="100000" sy="100000" kx="0" ky="0" algn="bl" rotWithShape="0" blurRad="101600" dist="38100" dir="5400000">
-              <a:srgbClr val="0B1E33">
-                <a:alpha val="12000"/>
-              </a:srgbClr>
-            </a:outerShdw>
-          </a:effectLst>
-        </p:spPr>
-      </p:sp>
-      <p:sp>
-        <p:nvSpPr>
-          <p:cNvPr id="10" name="Shape 7"/>
-          <p:cNvSpPr/>
-          <p:nvPr/>
-        </p:nvSpPr>
-        <p:spPr>
-          <a:xfrm>
-            <a:off x="4366260" y="2834640"/>
-            <a:ext cx="822960" cy="822960"/>
-          </a:xfrm>
-          <a:prstGeom prst="ellipse">
-            <a:avLst/>
-          </a:prstGeom>
-          <a:solidFill>
-            <a:srgbClr val="E3F4F4"/>
-          </a:solidFill>
-          <a:ln/>
-        </p:spPr>
-      </p:sp>
-      <p:pic>
-        <p:nvPicPr>
-          <p:cNvPr id="11" name="Image 1" descr="preencoded.png">    </p:cNvPr>
-          <p:cNvPicPr>
-            <a:picLocks noChangeAspect="1"/>
-          </p:cNvPicPr>
-          <p:nvPr/>
-        </p:nvPicPr>
-        <p:blipFill>
-          <a:blip r:embed="rId2"/>
-          <a:stretch>
-            <a:fillRect/>
-          </a:stretch>
-        </p:blipFill>
-        <p:spPr>
-          <a:xfrm>
-            <a:off x="4588459" y="3056839"/>
-            <a:ext cx="378562" cy="378562"/>
-          </a:xfrm>
-          <a:prstGeom prst="rect">
-            <a:avLst/>
-          </a:prstGeom>
-        </p:spPr>
-      </p:pic>
-      <p:sp>
-        <p:nvSpPr>
-          <p:cNvPr id="12" name="Text 8"/>
-          <p:cNvSpPr/>
-          <p:nvPr/>
-        </p:nvSpPr>
-        <p:spPr>
-          <a:xfrm>
-            <a:off x="3657600" y="3840480"/>
-            <a:ext cx="2240280" cy="548640"/>
-          </a:xfrm>
-          <a:prstGeom prst="rect">
-            <a:avLst/>
-          </a:prstGeom>
-          <a:noFill/>
-          <a:ln/>
-        </p:spPr>
-        <p:txBody>
-          <a:bodyPr wrap="square" lIns="0" tIns="0" rIns="0" bIns="0" rtlCol="0" anchor="ctr"/>
-          <a:lstStyle/>
-          <a:p>
-            <a:pPr algn="ctr" indent="0" marL="0">
-              <a:buNone/>
-            </a:pPr>
-            <a:r>
-              <a:rPr lang="en-US" sz="1500" b="1" dirty="0">
-                <a:solidFill>
-                  <a:srgbClr val="0B1E33"/>
-                </a:solidFill>
-                <a:latin typeface="Bookman Old Style" pitchFamily="34" charset="0"/>
-                <a:ea typeface="Bookman Old Style" pitchFamily="34" charset="-122"/>
-                <a:cs typeface="Bookman Old Style" pitchFamily="34" charset="-120"/>
-              </a:rPr>
-              <a:t>Обмін інформацією</a:t>
-            </a:r>
-            <a:endParaRPr lang="en-US" sz="1500" dirty="0"/>
-          </a:p>
-        </p:txBody>
-      </p:sp>
-      <p:sp>
-        <p:nvSpPr>
-          <p:cNvPr id="13" name="Text 9"/>
-          <p:cNvSpPr/>
-          <p:nvPr/>
-        </p:nvSpPr>
-        <p:spPr>
-          <a:xfrm>
-            <a:off x="3703320" y="4343400"/>
-            <a:ext cx="2148840" cy="1097280"/>
-          </a:xfrm>
-          <a:prstGeom prst="rect">
-            <a:avLst/>
-          </a:prstGeom>
-          <a:noFill/>
-          <a:ln/>
-        </p:spPr>
-        <p:txBody>
-          <a:bodyPr wrap="square" lIns="0" tIns="0" rIns="0" bIns="0" rtlCol="0" anchor="t"/>
-          <a:lstStyle/>
-          <a:p>
-            <a:pPr algn="ctr" indent="0" marL="0">
-              <a:buNone/>
-            </a:pPr>
-            <a:r>
-              <a:rPr lang="en-US" sz="1200" dirty="0">
-                <a:solidFill>
-                  <a:srgbClr val="3A4A57"/>
-                </a:solidFill>
-                <a:latin typeface="Calibri" pitchFamily="34" charset="0"/>
-                <a:ea typeface="Calibri" pitchFamily="34" charset="-122"/>
-                <a:cs typeface="Calibri" pitchFamily="34" charset="-120"/>
-              </a:rPr>
-              <a:t>CSV, JSON, TXT — формати для обміну між системами</a:t>
-            </a:r>
-            <a:endParaRPr lang="en-US" sz="1200" dirty="0"/>
-          </a:p>
-        </p:txBody>
-      </p:sp>
-      <p:sp>
-        <p:nvSpPr>
-          <p:cNvPr id="14" name="Shape 10"/>
-          <p:cNvSpPr/>
-          <p:nvPr/>
-        </p:nvSpPr>
-        <p:spPr>
-          <a:xfrm>
-            <a:off x="6400800" y="2468880"/>
-            <a:ext cx="2606040" cy="3108960"/>
-          </a:xfrm>
-          <a:prstGeom prst="roundRect">
-            <a:avLst>
-              <a:gd name="adj" fmla="val 4211"/>
-            </a:avLst>
-          </a:prstGeom>
-          <a:solidFill>
-            <a:srgbClr val="FFFFFF"/>
-          </a:solidFill>
-          <a:ln/>
-          <a:effectLst>
-            <a:outerShdw sx="100000" sy="100000" kx="0" ky="0" algn="bl" rotWithShape="0" blurRad="101600" dist="38100" dir="5400000">
-              <a:srgbClr val="0B1E33">
-                <a:alpha val="12000"/>
-              </a:srgbClr>
-            </a:outerShdw>
-          </a:effectLst>
-        </p:spPr>
-      </p:sp>
-      <p:sp>
-        <p:nvSpPr>
-          <p:cNvPr id="15" name="Shape 11"/>
-          <p:cNvSpPr/>
-          <p:nvPr/>
-        </p:nvSpPr>
-        <p:spPr>
-          <a:xfrm>
-            <a:off x="7292340" y="2834640"/>
-            <a:ext cx="822960" cy="822960"/>
-          </a:xfrm>
-          <a:prstGeom prst="ellipse">
-            <a:avLst/>
-          </a:prstGeom>
-          <a:solidFill>
-            <a:srgbClr val="E3F4F4"/>
-          </a:solidFill>
-          <a:ln/>
-        </p:spPr>
-      </p:sp>
-      <p:pic>
-        <p:nvPicPr>
-          <p:cNvPr id="16" name="Image 2" descr="preencoded.png">    </p:cNvPr>
+          <p:cNvPr id="6" name="Image 0" descr="preencoded.png"/>
           <p:cNvPicPr>
             <a:picLocks noChangeAspect="1"/>
           </p:cNvPicPr>
@@ -2331,7 +1909,7 @@
         </p:blipFill>
         <p:spPr>
           <a:xfrm>
-            <a:off x="7514539" y="3056839"/>
+            <a:off x="1662379" y="3056839"/>
             <a:ext cx="378562" cy="378562"/>
           </a:xfrm>
           <a:prstGeom prst="rect">
@@ -2341,13 +1919,13 @@
       </p:pic>
       <p:sp>
         <p:nvSpPr>
-          <p:cNvPr id="17" name="Text 12"/>
-          <p:cNvSpPr/>
-          <p:nvPr/>
-        </p:nvSpPr>
-        <p:spPr>
-          <a:xfrm>
-            <a:off x="6583680" y="3840480"/>
+          <p:cNvPr id="7" name="Text 4"/>
+          <p:cNvSpPr/>
+          <p:nvPr/>
+        </p:nvSpPr>
+        <p:spPr>
+          <a:xfrm>
+            <a:off x="731520" y="3840480"/>
             <a:ext cx="2240280" cy="548640"/>
           </a:xfrm>
           <a:prstGeom prst="rect">
@@ -2360,7 +1938,7 @@
           <a:bodyPr wrap="square" lIns="0" tIns="0" rIns="0" bIns="0" rtlCol="0" anchor="ctr"/>
           <a:lstStyle/>
           <a:p>
-            <a:pPr algn="ctr" indent="0" marL="0">
+            <a:pPr marL="0" indent="0" algn="ctr">
               <a:buNone/>
             </a:pPr>
             <a:r>
@@ -2372,7 +1950,7 @@
                 <a:ea typeface="Bookman Old Style" pitchFamily="34" charset="-122"/>
                 <a:cs typeface="Bookman Old Style" pitchFamily="34" charset="-120"/>
               </a:rPr>
-              <a:t>Логи та звіти</a:t>
+              <a:t>Збереження даних</a:t>
             </a:r>
             <a:endParaRPr lang="en-US" sz="1500" dirty="0"/>
           </a:p>
@@ -2380,13 +1958,13 @@
       </p:sp>
       <p:sp>
         <p:nvSpPr>
-          <p:cNvPr id="18" name="Text 13"/>
-          <p:cNvSpPr/>
-          <p:nvPr/>
-        </p:nvSpPr>
-        <p:spPr>
-          <a:xfrm>
-            <a:off x="6629400" y="4343400"/>
+          <p:cNvPr id="8" name="Text 5"/>
+          <p:cNvSpPr/>
+          <p:nvPr/>
+        </p:nvSpPr>
+        <p:spPr>
+          <a:xfrm>
+            <a:off x="777240" y="4343400"/>
             <a:ext cx="2148840" cy="1097280"/>
           </a:xfrm>
           <a:prstGeom prst="rect">
@@ -2399,7 +1977,7 @@
           <a:bodyPr wrap="square" lIns="0" tIns="0" rIns="0" bIns="0" rtlCol="0" anchor="t"/>
           <a:lstStyle/>
           <a:p>
-            <a:pPr algn="ctr" indent="0" marL="0">
+            <a:pPr marL="0" indent="0" algn="ctr">
               <a:buNone/>
             </a:pPr>
             <a:r>
@@ -2411,7 +1989,7 @@
                 <a:ea typeface="Calibri" pitchFamily="34" charset="-122"/>
                 <a:cs typeface="Calibri" pitchFamily="34" charset="-120"/>
               </a:rPr>
-              <a:t>Запис історії подій, помилок, статистики роботи програми</a:t>
+              <a:t>Результати роботи програми не зникають після закриття</a:t>
             </a:r>
             <a:endParaRPr lang="en-US" sz="1200" dirty="0"/>
           </a:p>
@@ -2419,13 +1997,13 @@
       </p:sp>
       <p:sp>
         <p:nvSpPr>
-          <p:cNvPr id="19" name="Shape 14"/>
-          <p:cNvSpPr/>
-          <p:nvPr/>
-        </p:nvSpPr>
-        <p:spPr>
-          <a:xfrm>
-            <a:off x="9326880" y="2468880"/>
+          <p:cNvPr id="9" name="Shape 6"/>
+          <p:cNvSpPr/>
+          <p:nvPr/>
+        </p:nvSpPr>
+        <p:spPr>
+          <a:xfrm>
+            <a:off x="3474720" y="2468880"/>
             <a:ext cx="2606040" cy="3108960"/>
           </a:xfrm>
           <a:prstGeom prst="roundRect">
@@ -2438,23 +2016,30 @@
           </a:solidFill>
           <a:ln/>
           <a:effectLst>
-            <a:outerShdw sx="100000" sy="100000" kx="0" ky="0" algn="bl" rotWithShape="0" blurRad="101600" dist="38100" dir="5400000">
+            <a:outerShdw blurRad="101600" dist="38100" dir="5400000" algn="bl" rotWithShape="0">
               <a:srgbClr val="0B1E33">
                 <a:alpha val="12000"/>
               </a:srgbClr>
             </a:outerShdw>
           </a:effectLst>
         </p:spPr>
-      </p:sp>
-      <p:sp>
-        <p:nvSpPr>
-          <p:cNvPr id="20" name="Shape 15"/>
-          <p:cNvSpPr/>
-          <p:nvPr/>
-        </p:nvSpPr>
-        <p:spPr>
-          <a:xfrm>
-            <a:off x="10218420" y="2834640"/>
+        <p:txBody>
+          <a:bodyPr/>
+          <a:lstStyle/>
+          <a:p>
+            <a:endParaRPr lang="en-UA"/>
+          </a:p>
+        </p:txBody>
+      </p:sp>
+      <p:sp>
+        <p:nvSpPr>
+          <p:cNvPr id="10" name="Shape 7"/>
+          <p:cNvSpPr/>
+          <p:nvPr/>
+        </p:nvSpPr>
+        <p:spPr>
+          <a:xfrm>
+            <a:off x="4366260" y="2834640"/>
             <a:ext cx="822960" cy="822960"/>
           </a:xfrm>
           <a:prstGeom prst="ellipse">
@@ -2465,10 +2050,17 @@
           </a:solidFill>
           <a:ln/>
         </p:spPr>
+        <p:txBody>
+          <a:bodyPr/>
+          <a:lstStyle/>
+          <a:p>
+            <a:endParaRPr lang="en-UA"/>
+          </a:p>
+        </p:txBody>
       </p:sp>
       <p:pic>
         <p:nvPicPr>
-          <p:cNvPr id="21" name="Image 3" descr="preencoded.png">    </p:cNvPr>
+          <p:cNvPr id="11" name="Image 1" descr="preencoded.png"/>
           <p:cNvPicPr>
             <a:picLocks noChangeAspect="1"/>
           </p:cNvPicPr>
@@ -2482,7 +2074,7 @@
         </p:blipFill>
         <p:spPr>
           <a:xfrm>
-            <a:off x="10440619" y="3056839"/>
+            <a:off x="4588459" y="3056839"/>
             <a:ext cx="378562" cy="378562"/>
           </a:xfrm>
           <a:prstGeom prst="rect">
@@ -2492,13 +2084,13 @@
       </p:pic>
       <p:sp>
         <p:nvSpPr>
-          <p:cNvPr id="22" name="Text 16"/>
-          <p:cNvSpPr/>
-          <p:nvPr/>
-        </p:nvSpPr>
-        <p:spPr>
-          <a:xfrm>
-            <a:off x="9509760" y="3840480"/>
+          <p:cNvPr id="12" name="Text 8"/>
+          <p:cNvSpPr/>
+          <p:nvPr/>
+        </p:nvSpPr>
+        <p:spPr>
+          <a:xfrm>
+            <a:off x="3657600" y="3840480"/>
             <a:ext cx="2240280" cy="548640"/>
           </a:xfrm>
           <a:prstGeom prst="rect">
@@ -2511,7 +2103,7 @@
           <a:bodyPr wrap="square" lIns="0" tIns="0" rIns="0" bIns="0" rtlCol="0" anchor="ctr"/>
           <a:lstStyle/>
           <a:p>
-            <a:pPr algn="ctr" indent="0" marL="0">
+            <a:pPr marL="0" indent="0" algn="ctr">
               <a:buNone/>
             </a:pPr>
             <a:r>
@@ -2523,7 +2115,7 @@
                 <a:ea typeface="Bookman Old Style" pitchFamily="34" charset="-122"/>
                 <a:cs typeface="Bookman Old Style" pitchFamily="34" charset="-120"/>
               </a:rPr>
-              <a:t>Конфігурації</a:t>
+              <a:t>Обмін інформацією</a:t>
             </a:r>
             <a:endParaRPr lang="en-US" sz="1500" dirty="0"/>
           </a:p>
@@ -2531,13 +2123,13 @@
       </p:sp>
       <p:sp>
         <p:nvSpPr>
-          <p:cNvPr id="23" name="Text 17"/>
-          <p:cNvSpPr/>
-          <p:nvPr/>
-        </p:nvSpPr>
-        <p:spPr>
-          <a:xfrm>
-            <a:off x="9555480" y="4343400"/>
+          <p:cNvPr id="13" name="Text 9"/>
+          <p:cNvSpPr/>
+          <p:nvPr/>
+        </p:nvSpPr>
+        <p:spPr>
+          <a:xfrm>
+            <a:off x="3703320" y="4343400"/>
             <a:ext cx="2148840" cy="1097280"/>
           </a:xfrm>
           <a:prstGeom prst="rect">
@@ -2550,7 +2142,7 @@
           <a:bodyPr wrap="square" lIns="0" tIns="0" rIns="0" bIns="0" rtlCol="0" anchor="t"/>
           <a:lstStyle/>
           <a:p>
-            <a:pPr algn="ctr" indent="0" marL="0">
+            <a:pPr marL="0" indent="0" algn="ctr">
               <a:buNone/>
             </a:pPr>
             <a:r>
@@ -2562,7 +2154,7 @@
                 <a:ea typeface="Calibri" pitchFamily="34" charset="-122"/>
                 <a:cs typeface="Calibri" pitchFamily="34" charset="-120"/>
               </a:rPr>
-              <a:t>Налаштування програми зберігаються окремо від коду</a:t>
+              <a:t>CSV, JSON, TXT — формати для обміну між системами</a:t>
             </a:r>
             <a:endParaRPr lang="en-US" sz="1200" dirty="0"/>
           </a:p>
@@ -2570,37 +2162,367 @@
       </p:sp>
       <p:sp>
         <p:nvSpPr>
-          <p:cNvPr id="24" name="Text 18"/>
-          <p:cNvSpPr/>
-          <p:nvPr/>
-        </p:nvSpPr>
-        <p:spPr>
-          <a:xfrm>
-            <a:off x="457200" y="6473952"/>
-            <a:ext cx="5486400" cy="274320"/>
+          <p:cNvPr id="14" name="Shape 10"/>
+          <p:cNvSpPr/>
+          <p:nvPr/>
+        </p:nvSpPr>
+        <p:spPr>
+          <a:xfrm>
+            <a:off x="6400800" y="2468880"/>
+            <a:ext cx="2606040" cy="3108960"/>
+          </a:xfrm>
+          <a:prstGeom prst="roundRect">
+            <a:avLst>
+              <a:gd name="adj" fmla="val 4211"/>
+            </a:avLst>
+          </a:prstGeom>
+          <a:solidFill>
+            <a:srgbClr val="FFFFFF"/>
+          </a:solidFill>
+          <a:ln/>
+          <a:effectLst>
+            <a:outerShdw blurRad="101600" dist="38100" dir="5400000" algn="bl" rotWithShape="0">
+              <a:srgbClr val="0B1E33">
+                <a:alpha val="12000"/>
+              </a:srgbClr>
+            </a:outerShdw>
+          </a:effectLst>
+        </p:spPr>
+        <p:txBody>
+          <a:bodyPr/>
+          <a:lstStyle/>
+          <a:p>
+            <a:endParaRPr lang="en-UA"/>
+          </a:p>
+        </p:txBody>
+      </p:sp>
+      <p:sp>
+        <p:nvSpPr>
+          <p:cNvPr id="15" name="Shape 11"/>
+          <p:cNvSpPr/>
+          <p:nvPr/>
+        </p:nvSpPr>
+        <p:spPr>
+          <a:xfrm>
+            <a:off x="7292340" y="2834640"/>
+            <a:ext cx="822960" cy="822960"/>
+          </a:xfrm>
+          <a:prstGeom prst="ellipse">
+            <a:avLst/>
+          </a:prstGeom>
+          <a:solidFill>
+            <a:srgbClr val="E3F4F4"/>
+          </a:solidFill>
+          <a:ln/>
+        </p:spPr>
+        <p:txBody>
+          <a:bodyPr/>
+          <a:lstStyle/>
+          <a:p>
+            <a:endParaRPr lang="en-UA"/>
+          </a:p>
+        </p:txBody>
+      </p:sp>
+      <p:pic>
+        <p:nvPicPr>
+          <p:cNvPr id="16" name="Image 2" descr="preencoded.png"/>
+          <p:cNvPicPr>
+            <a:picLocks noChangeAspect="1"/>
+          </p:cNvPicPr>
+          <p:nvPr/>
+        </p:nvPicPr>
+        <p:blipFill>
+          <a:blip r:embed="rId5"/>
+          <a:stretch>
+            <a:fillRect/>
+          </a:stretch>
+        </p:blipFill>
+        <p:spPr>
+          <a:xfrm>
+            <a:off x="7514539" y="3056839"/>
+            <a:ext cx="378562" cy="378562"/>
           </a:xfrm>
           <a:prstGeom prst="rect">
             <a:avLst/>
           </a:prstGeom>
+        </p:spPr>
+      </p:pic>
+      <p:sp>
+        <p:nvSpPr>
+          <p:cNvPr id="17" name="Text 12"/>
+          <p:cNvSpPr/>
+          <p:nvPr/>
+        </p:nvSpPr>
+        <p:spPr>
+          <a:xfrm>
+            <a:off x="6583680" y="3840480"/>
+            <a:ext cx="2240280" cy="548640"/>
+          </a:xfrm>
+          <a:prstGeom prst="rect">
+            <a:avLst/>
+          </a:prstGeom>
           <a:noFill/>
           <a:ln/>
         </p:spPr>
         <p:txBody>
-          <a:bodyPr wrap="square" rtlCol="0" anchor="ctr"/>
-          <a:lstStyle/>
-          <a:p>
-            <a:pPr indent="0" marL="0">
-              <a:buNone/>
-            </a:pPr>
-            <a:r>
-              <a:rPr lang="en-US" sz="1000" dirty="0">
-                <a:solidFill>
-                  <a:srgbClr val="8FA6AE"/>
+          <a:bodyPr wrap="square" lIns="0" tIns="0" rIns="0" bIns="0" rtlCol="0" anchor="ctr"/>
+          <a:lstStyle/>
+          <a:p>
+            <a:pPr marL="0" indent="0" algn="ctr">
+              <a:buNone/>
+            </a:pPr>
+            <a:r>
+              <a:rPr lang="en-US" sz="1500" b="1" dirty="0">
+                <a:solidFill>
+                  <a:srgbClr val="0B1E33"/>
+                </a:solidFill>
+                <a:latin typeface="Bookman Old Style" pitchFamily="34" charset="0"/>
+                <a:ea typeface="Bookman Old Style" pitchFamily="34" charset="-122"/>
+                <a:cs typeface="Bookman Old Style" pitchFamily="34" charset="-120"/>
+              </a:rPr>
+              <a:t>Логи та звіти</a:t>
+            </a:r>
+            <a:endParaRPr lang="en-US" sz="1500" dirty="0"/>
+          </a:p>
+        </p:txBody>
+      </p:sp>
+      <p:sp>
+        <p:nvSpPr>
+          <p:cNvPr id="18" name="Text 13"/>
+          <p:cNvSpPr/>
+          <p:nvPr/>
+        </p:nvSpPr>
+        <p:spPr>
+          <a:xfrm>
+            <a:off x="6629400" y="4343400"/>
+            <a:ext cx="2148840" cy="1097280"/>
+          </a:xfrm>
+          <a:prstGeom prst="rect">
+            <a:avLst/>
+          </a:prstGeom>
+          <a:noFill/>
+          <a:ln/>
+        </p:spPr>
+        <p:txBody>
+          <a:bodyPr wrap="square" lIns="0" tIns="0" rIns="0" bIns="0" rtlCol="0" anchor="t"/>
+          <a:lstStyle/>
+          <a:p>
+            <a:pPr marL="0" indent="0" algn="ctr">
+              <a:buNone/>
+            </a:pPr>
+            <a:r>
+              <a:rPr lang="en-US" sz="1200" dirty="0">
+                <a:solidFill>
+                  <a:srgbClr val="3A4A57"/>
                 </a:solidFill>
                 <a:latin typeface="Calibri" pitchFamily="34" charset="0"/>
                 <a:ea typeface="Calibri" pitchFamily="34" charset="-122"/>
                 <a:cs typeface="Calibri" pitchFamily="34" charset="-120"/>
               </a:rPr>
+              <a:t>Запис історії подій, помилок, статистики роботи програми</a:t>
+            </a:r>
+            <a:endParaRPr lang="en-US" sz="1200" dirty="0"/>
+          </a:p>
+        </p:txBody>
+      </p:sp>
+      <p:sp>
+        <p:nvSpPr>
+          <p:cNvPr id="19" name="Shape 14"/>
+          <p:cNvSpPr/>
+          <p:nvPr/>
+        </p:nvSpPr>
+        <p:spPr>
+          <a:xfrm>
+            <a:off x="9326880" y="2468880"/>
+            <a:ext cx="2606040" cy="3108960"/>
+          </a:xfrm>
+          <a:prstGeom prst="roundRect">
+            <a:avLst>
+              <a:gd name="adj" fmla="val 4211"/>
+            </a:avLst>
+          </a:prstGeom>
+          <a:solidFill>
+            <a:srgbClr val="FFFFFF"/>
+          </a:solidFill>
+          <a:ln/>
+          <a:effectLst>
+            <a:outerShdw blurRad="101600" dist="38100" dir="5400000" algn="bl" rotWithShape="0">
+              <a:srgbClr val="0B1E33">
+                <a:alpha val="12000"/>
+              </a:srgbClr>
+            </a:outerShdw>
+          </a:effectLst>
+        </p:spPr>
+        <p:txBody>
+          <a:bodyPr/>
+          <a:lstStyle/>
+          <a:p>
+            <a:endParaRPr lang="en-UA"/>
+          </a:p>
+        </p:txBody>
+      </p:sp>
+      <p:sp>
+        <p:nvSpPr>
+          <p:cNvPr id="20" name="Shape 15"/>
+          <p:cNvSpPr/>
+          <p:nvPr/>
+        </p:nvSpPr>
+        <p:spPr>
+          <a:xfrm>
+            <a:off x="10218420" y="2834640"/>
+            <a:ext cx="822960" cy="822960"/>
+          </a:xfrm>
+          <a:prstGeom prst="ellipse">
+            <a:avLst/>
+          </a:prstGeom>
+          <a:solidFill>
+            <a:srgbClr val="E3F4F4"/>
+          </a:solidFill>
+          <a:ln/>
+        </p:spPr>
+        <p:txBody>
+          <a:bodyPr/>
+          <a:lstStyle/>
+          <a:p>
+            <a:endParaRPr lang="en-UA"/>
+          </a:p>
+        </p:txBody>
+      </p:sp>
+      <p:pic>
+        <p:nvPicPr>
+          <p:cNvPr id="21" name="Image 3" descr="preencoded.png"/>
+          <p:cNvPicPr>
+            <a:picLocks noChangeAspect="1"/>
+          </p:cNvPicPr>
+          <p:nvPr/>
+        </p:nvPicPr>
+        <p:blipFill>
+          <a:blip r:embed="rId6"/>
+          <a:stretch>
+            <a:fillRect/>
+          </a:stretch>
+        </p:blipFill>
+        <p:spPr>
+          <a:xfrm>
+            <a:off x="10440619" y="3056839"/>
+            <a:ext cx="378562" cy="378562"/>
+          </a:xfrm>
+          <a:prstGeom prst="rect">
+            <a:avLst/>
+          </a:prstGeom>
+        </p:spPr>
+      </p:pic>
+      <p:sp>
+        <p:nvSpPr>
+          <p:cNvPr id="22" name="Text 16"/>
+          <p:cNvSpPr/>
+          <p:nvPr/>
+        </p:nvSpPr>
+        <p:spPr>
+          <a:xfrm>
+            <a:off x="9509760" y="3840480"/>
+            <a:ext cx="2240280" cy="548640"/>
+          </a:xfrm>
+          <a:prstGeom prst="rect">
+            <a:avLst/>
+          </a:prstGeom>
+          <a:noFill/>
+          <a:ln/>
+        </p:spPr>
+        <p:txBody>
+          <a:bodyPr wrap="square" lIns="0" tIns="0" rIns="0" bIns="0" rtlCol="0" anchor="ctr"/>
+          <a:lstStyle/>
+          <a:p>
+            <a:pPr marL="0" indent="0" algn="ctr">
+              <a:buNone/>
+            </a:pPr>
+            <a:r>
+              <a:rPr lang="en-US" sz="1500" b="1" dirty="0">
+                <a:solidFill>
+                  <a:srgbClr val="0B1E33"/>
+                </a:solidFill>
+                <a:latin typeface="Bookman Old Style" pitchFamily="34" charset="0"/>
+                <a:ea typeface="Bookman Old Style" pitchFamily="34" charset="-122"/>
+                <a:cs typeface="Bookman Old Style" pitchFamily="34" charset="-120"/>
+              </a:rPr>
+              <a:t>Конфігурації</a:t>
+            </a:r>
+            <a:endParaRPr lang="en-US" sz="1500" dirty="0"/>
+          </a:p>
+        </p:txBody>
+      </p:sp>
+      <p:sp>
+        <p:nvSpPr>
+          <p:cNvPr id="23" name="Text 17"/>
+          <p:cNvSpPr/>
+          <p:nvPr/>
+        </p:nvSpPr>
+        <p:spPr>
+          <a:xfrm>
+            <a:off x="9555480" y="4343400"/>
+            <a:ext cx="2148840" cy="1097280"/>
+          </a:xfrm>
+          <a:prstGeom prst="rect">
+            <a:avLst/>
+          </a:prstGeom>
+          <a:noFill/>
+          <a:ln/>
+        </p:spPr>
+        <p:txBody>
+          <a:bodyPr wrap="square" lIns="0" tIns="0" rIns="0" bIns="0" rtlCol="0" anchor="t"/>
+          <a:lstStyle/>
+          <a:p>
+            <a:pPr marL="0" indent="0" algn="ctr">
+              <a:buNone/>
+            </a:pPr>
+            <a:r>
+              <a:rPr lang="en-US" sz="1200" dirty="0">
+                <a:solidFill>
+                  <a:srgbClr val="3A4A57"/>
+                </a:solidFill>
+                <a:latin typeface="Calibri" pitchFamily="34" charset="0"/>
+                <a:ea typeface="Calibri" pitchFamily="34" charset="-122"/>
+                <a:cs typeface="Calibri" pitchFamily="34" charset="-120"/>
+              </a:rPr>
+              <a:t>Налаштування програми зберігаються окремо від коду</a:t>
+            </a:r>
+            <a:endParaRPr lang="en-US" sz="1200" dirty="0"/>
+          </a:p>
+        </p:txBody>
+      </p:sp>
+      <p:sp>
+        <p:nvSpPr>
+          <p:cNvPr id="24" name="Text 18"/>
+          <p:cNvSpPr/>
+          <p:nvPr/>
+        </p:nvSpPr>
+        <p:spPr>
+          <a:xfrm>
+            <a:off x="457200" y="6473952"/>
+            <a:ext cx="5486400" cy="274320"/>
+          </a:xfrm>
+          <a:prstGeom prst="rect">
+            <a:avLst/>
+          </a:prstGeom>
+          <a:noFill/>
+          <a:ln/>
+        </p:spPr>
+        <p:txBody>
+          <a:bodyPr wrap="square" rtlCol="0" anchor="ctr"/>
+          <a:lstStyle/>
+          <a:p>
+            <a:pPr marL="0" indent="0">
+              <a:buNone/>
+            </a:pPr>
+            <a:r>
+              <a:rPr lang="en-US" sz="1000" dirty="0">
+                <a:solidFill>
+                  <a:srgbClr val="8FA6AE"/>
+                </a:solidFill>
+                <a:latin typeface="Calibri" pitchFamily="34" charset="0"/>
+                <a:ea typeface="Calibri" pitchFamily="34" charset="-122"/>
+                <a:cs typeface="Calibri" pitchFamily="34" charset="-120"/>
+              </a:rPr>
               <a:t>Python: робота з файлами</a:t>
             </a:r>
             <a:endParaRPr lang="en-US" sz="1000" dirty="0"/>
@@ -2628,7 +2550,7 @@
           <a:bodyPr wrap="square" rtlCol="0" anchor="ctr"/>
           <a:lstStyle/>
           <a:p>
-            <a:pPr algn="r" indent="0" marL="0">
+            <a:pPr marL="0" indent="0" algn="r">
               <a:buNone/>
             </a:pPr>
             <a:r>
@@ -2662,6 +2584,7 @@
         <a:solidFill>
           <a:srgbClr val="FFFFFF"/>
         </a:solidFill>
+        <a:effectLst/>
       </p:bgPr>
     </p:bg>
     <p:spTree>
@@ -2699,7 +2622,7 @@
           <a:bodyPr wrap="square" lIns="0" tIns="0" rIns="0" bIns="0" rtlCol="0" anchor="ctr"/>
           <a:lstStyle/>
           <a:p>
-            <a:pPr indent="0" marL="0">
+            <a:pPr marL="0" indent="0">
               <a:buNone/>
             </a:pPr>
             <a:r>
@@ -2738,7 +2661,7 @@
           <a:bodyPr wrap="square" lIns="0" tIns="0" rIns="0" bIns="0" rtlCol="0" anchor="ctr"/>
           <a:lstStyle/>
           <a:p>
-            <a:pPr indent="0" marL="0">
+            <a:pPr marL="0" indent="0">
               <a:buNone/>
             </a:pPr>
             <a:r>
@@ -2782,6 +2705,13 @@
             <a:prstDash val="solid"/>
           </a:ln>
         </p:spPr>
+        <p:txBody>
+          <a:bodyPr/>
+          <a:lstStyle/>
+          <a:p>
+            <a:endParaRPr lang="en-UA"/>
+          </a:p>
+        </p:txBody>
       </p:sp>
       <p:sp>
         <p:nvSpPr>
@@ -2802,6 +2732,13 @@
           </a:solidFill>
           <a:ln/>
         </p:spPr>
+        <p:txBody>
+          <a:bodyPr/>
+          <a:lstStyle/>
+          <a:p>
+            <a:endParaRPr lang="en-UA"/>
+          </a:p>
+        </p:txBody>
       </p:sp>
       <p:sp>
         <p:nvSpPr>
@@ -2822,6 +2759,13 @@
           </a:solidFill>
           <a:ln/>
         </p:spPr>
+        <p:txBody>
+          <a:bodyPr/>
+          <a:lstStyle/>
+          <a:p>
+            <a:endParaRPr lang="en-UA"/>
+          </a:p>
+        </p:txBody>
       </p:sp>
       <p:sp>
         <p:nvSpPr>
@@ -2842,6 +2786,13 @@
           </a:solidFill>
           <a:ln/>
         </p:spPr>
+        <p:txBody>
+          <a:bodyPr/>
+          <a:lstStyle/>
+          <a:p>
+            <a:endParaRPr lang="en-UA"/>
+          </a:p>
+        </p:txBody>
       </p:sp>
       <p:sp>
         <p:nvSpPr>
@@ -2864,7 +2815,7 @@
           <a:bodyPr wrap="square" lIns="0" tIns="0" rIns="0" bIns="0" rtlCol="0" anchor="t"/>
           <a:lstStyle/>
           <a:p>
-            <a:pPr indent="0" marL="0">
+            <a:pPr marL="0" indent="0">
               <a:lnSpc>
                 <a:spcPct val="115000"/>
               </a:lnSpc>
@@ -2884,7 +2835,7 @@
             <a:endParaRPr lang="en-US" sz="1400" dirty="0"/>
           </a:p>
           <a:p>
-            <a:pPr indent="0" marL="0">
+            <a:pPr marL="0" indent="0">
               <a:lnSpc>
                 <a:spcPct val="115000"/>
               </a:lnSpc>
@@ -2904,7 +2855,7 @@
             <a:endParaRPr lang="en-US" sz="1400" dirty="0"/>
           </a:p>
           <a:p>
-            <a:pPr indent="0" marL="0">
+            <a:pPr marL="0" indent="0">
               <a:lnSpc>
                 <a:spcPct val="115000"/>
               </a:lnSpc>
@@ -2913,7 +2864,7 @@
             <a:endParaRPr lang="en-US" sz="1400" dirty="0"/>
           </a:p>
           <a:p>
-            <a:pPr indent="0" marL="0">
+            <a:pPr marL="0" indent="0">
               <a:lnSpc>
                 <a:spcPct val="115000"/>
               </a:lnSpc>
@@ -2933,7 +2884,7 @@
             <a:endParaRPr lang="en-US" sz="1400" dirty="0"/>
           </a:p>
           <a:p>
-            <a:pPr indent="0" marL="0">
+            <a:pPr marL="0" indent="0">
               <a:lnSpc>
                 <a:spcPct val="115000"/>
               </a:lnSpc>
@@ -2975,7 +2926,7 @@
           <a:bodyPr wrap="square" lIns="0" tIns="0" rIns="0" bIns="0" rtlCol="0" anchor="ctr"/>
           <a:lstStyle/>
           <a:p>
-            <a:pPr indent="0" marL="0">
+            <a:pPr marL="0" indent="0">
               <a:buNone/>
             </a:pPr>
             <a:r>
@@ -3014,7 +2965,7 @@
           <a:bodyPr wrap="square" lIns="0" tIns="0" rIns="0" bIns="0" rtlCol="0" anchor="ctr"/>
           <a:lstStyle/>
           <a:p>
-            <a:pPr indent="0" marL="0">
+            <a:pPr marL="0" indent="0">
               <a:buNone/>
             </a:pPr>
             <a:r>
@@ -3034,7 +2985,7 @@
       </p:sp>
       <p:graphicFrame>
         <p:nvGraphicFramePr>
-          <p:cNvPr id="4" name="Table 0"/>
+          <p:cNvPr id="11" name="Table 0"/>
           <p:cNvGraphicFramePr>
             <a:graphicFrameLocks noGrp="1"/>
           </p:cNvGraphicFramePr>
@@ -3048,15 +2999,27 @@
         </p:nvGraphicFramePr>
         <p:xfrm>
           <a:off x="6400800" y="1280160"/>
-          <a:ext cx="5212080" cy="4480560"/>
+          <a:ext cx="5212080" cy="3246120"/>
         </p:xfrm>
         <a:graphic>
           <a:graphicData uri="http://schemas.openxmlformats.org/drawingml/2006/table">
             <a:tbl>
               <a:tblPr/>
               <a:tblGrid>
-                <a:gridCol w="2606040"/>
-                <a:gridCol w="2606040"/>
+                <a:gridCol w="2606040">
+                  <a:extLst>
+                    <a:ext uri="{9D8B030D-6E8A-4147-A177-3AD203B41FA5}">
+                      <a16:colId xmlns:a16="http://schemas.microsoft.com/office/drawing/2014/main" val="20000"/>
+                    </a:ext>
+                  </a:extLst>
+                </a:gridCol>
+                <a:gridCol w="2606040">
+                  <a:extLst>
+                    <a:ext uri="{9D8B030D-6E8A-4147-A177-3AD203B41FA5}">
+                      <a16:colId xmlns:a16="http://schemas.microsoft.com/office/drawing/2014/main" val="20001"/>
+                    </a:ext>
+                  </a:extLst>
+                </a:gridCol>
               </a:tblGrid>
               <a:tr h="502920">
                 <a:tc>
@@ -3064,7 +3027,7 @@
                     <a:bodyPr/>
                     <a:lstStyle/>
                     <a:p>
-                      <a:pPr indent="0" marL="0">
+                      <a:pPr marL="0" indent="0">
                         <a:buNone/>
                       </a:pPr>
                       <a:r>
@@ -3085,7 +3048,7 @@
                       </a:endParaRPr>
                     </a:p>
                   </a:txBody>
-                  <a:tcPr marL="91440" marR="91440" marT="45720" marB="45720" anchor="ctr">
+                  <a:tcPr anchor="ctr">
                     <a:lnL w="6350" cap="flat" cmpd="sng" algn="ctr">
                       <a:solidFill>
                         <a:srgbClr val="DCE7E9"/>
@@ -3132,7 +3095,7 @@
                     <a:bodyPr/>
                     <a:lstStyle/>
                     <a:p>
-                      <a:pPr indent="0" marL="0">
+                      <a:pPr marL="0" indent="0">
                         <a:buNone/>
                       </a:pPr>
                       <a:r>
@@ -3153,7 +3116,7 @@
                       </a:endParaRPr>
                     </a:p>
                   </a:txBody>
-                  <a:tcPr marL="91440" marR="91440" marT="45720" marB="45720" anchor="ctr">
+                  <a:tcPr anchor="ctr">
                     <a:lnL w="6350" cap="flat" cmpd="sng" algn="ctr">
                       <a:solidFill>
                         <a:srgbClr val="DCE7E9"/>
@@ -3195,6 +3158,11 @@
                     </a:solidFill>
                   </a:tcPr>
                 </a:tc>
+                <a:extLst>
+                  <a:ext uri="{0D108BD9-81ED-4DB2-BD59-A6C34878D82A}">
+                    <a16:rowId xmlns:a16="http://schemas.microsoft.com/office/drawing/2014/main" val="10000"/>
+                  </a:ext>
+                </a:extLst>
               </a:tr>
               <a:tr h="548640">
                 <a:tc>
@@ -3202,7 +3170,7 @@
                     <a:bodyPr/>
                     <a:lstStyle/>
                     <a:p>
-                      <a:pPr indent="0" marL="0">
+                      <a:pPr marL="0" indent="0">
                         <a:buNone/>
                       </a:pPr>
                       <a:r>
@@ -3223,7 +3191,7 @@
                       </a:endParaRPr>
                     </a:p>
                   </a:txBody>
-                  <a:tcPr marL="91440" marR="91440" marT="45720" marB="45720" anchor="ctr">
+                  <a:tcPr anchor="ctr">
                     <a:lnL w="6350" cap="flat" cmpd="sng" algn="ctr">
                       <a:solidFill>
                         <a:srgbClr val="DCE7E9"/>
@@ -3267,7 +3235,7 @@
                     <a:bodyPr/>
                     <a:lstStyle/>
                     <a:p>
-                      <a:pPr indent="0" marL="0">
+                      <a:pPr marL="0" indent="0">
                         <a:buNone/>
                       </a:pPr>
                       <a:r>
@@ -3288,7 +3256,7 @@
                       </a:endParaRPr>
                     </a:p>
                   </a:txBody>
-                  <a:tcPr marL="91440" marR="91440" marT="45720" marB="45720" anchor="ctr">
+                  <a:tcPr anchor="ctr">
                     <a:lnL w="6350" cap="flat" cmpd="sng" algn="ctr">
                       <a:solidFill>
                         <a:srgbClr val="DCE7E9"/>
@@ -3327,6 +3295,11 @@
                     </a:lnB>
                   </a:tcPr>
                 </a:tc>
+                <a:extLst>
+                  <a:ext uri="{0D108BD9-81ED-4DB2-BD59-A6C34878D82A}">
+                    <a16:rowId xmlns:a16="http://schemas.microsoft.com/office/drawing/2014/main" val="10001"/>
+                  </a:ext>
+                </a:extLst>
               </a:tr>
               <a:tr h="548640">
                 <a:tc>
@@ -3334,7 +3307,7 @@
                     <a:bodyPr/>
                     <a:lstStyle/>
                     <a:p>
-                      <a:pPr indent="0" marL="0">
+                      <a:pPr marL="0" indent="0">
                         <a:buNone/>
                       </a:pPr>
                       <a:r>
@@ -3355,7 +3328,7 @@
                       </a:endParaRPr>
                     </a:p>
                   </a:txBody>
-                  <a:tcPr marL="91440" marR="91440" marT="45720" marB="45720" anchor="ctr">
+                  <a:tcPr anchor="ctr">
                     <a:lnL w="6350" cap="flat" cmpd="sng" algn="ctr">
                       <a:solidFill>
                         <a:srgbClr val="DCE7E9"/>
@@ -3399,7 +3372,7 @@
                     <a:bodyPr/>
                     <a:lstStyle/>
                     <a:p>
-                      <a:pPr indent="0" marL="0">
+                      <a:pPr marL="0" indent="0">
                         <a:buNone/>
                       </a:pPr>
                       <a:r>
@@ -3420,7 +3393,7 @@
                       </a:endParaRPr>
                     </a:p>
                   </a:txBody>
-                  <a:tcPr marL="91440" marR="91440" marT="45720" marB="45720" anchor="ctr">
+                  <a:tcPr anchor="ctr">
                     <a:lnL w="6350" cap="flat" cmpd="sng" algn="ctr">
                       <a:solidFill>
                         <a:srgbClr val="DCE7E9"/>
@@ -3459,6 +3432,11 @@
                     </a:lnB>
                   </a:tcPr>
                 </a:tc>
+                <a:extLst>
+                  <a:ext uri="{0D108BD9-81ED-4DB2-BD59-A6C34878D82A}">
+                    <a16:rowId xmlns:a16="http://schemas.microsoft.com/office/drawing/2014/main" val="10002"/>
+                  </a:ext>
+                </a:extLst>
               </a:tr>
               <a:tr h="548640">
                 <a:tc>
@@ -3466,7 +3444,7 @@
                     <a:bodyPr/>
                     <a:lstStyle/>
                     <a:p>
-                      <a:pPr indent="0" marL="0">
+                      <a:pPr marL="0" indent="0">
                         <a:buNone/>
                       </a:pPr>
                       <a:r>
@@ -3487,7 +3465,7 @@
                       </a:endParaRPr>
                     </a:p>
                   </a:txBody>
-                  <a:tcPr marL="91440" marR="91440" marT="45720" marB="45720" anchor="ctr">
+                  <a:tcPr anchor="ctr">
                     <a:lnL w="6350" cap="flat" cmpd="sng" algn="ctr">
                       <a:solidFill>
                         <a:srgbClr val="DCE7E9"/>
@@ -3531,7 +3509,7 @@
                     <a:bodyPr/>
                     <a:lstStyle/>
                     <a:p>
-                      <a:pPr indent="0" marL="0">
+                      <a:pPr marL="0" indent="0">
                         <a:buNone/>
                       </a:pPr>
                       <a:r>
@@ -3552,7 +3530,7 @@
                       </a:endParaRPr>
                     </a:p>
                   </a:txBody>
-                  <a:tcPr marL="91440" marR="91440" marT="45720" marB="45720" anchor="ctr">
+                  <a:tcPr anchor="ctr">
                     <a:lnL w="6350" cap="flat" cmpd="sng" algn="ctr">
                       <a:solidFill>
                         <a:srgbClr val="DCE7E9"/>
@@ -3591,6 +3569,11 @@
                     </a:lnB>
                   </a:tcPr>
                 </a:tc>
+                <a:extLst>
+                  <a:ext uri="{0D108BD9-81ED-4DB2-BD59-A6C34878D82A}">
+                    <a16:rowId xmlns:a16="http://schemas.microsoft.com/office/drawing/2014/main" val="10003"/>
+                  </a:ext>
+                </a:extLst>
               </a:tr>
               <a:tr h="548640">
                 <a:tc>
@@ -3598,7 +3581,7 @@
                     <a:bodyPr/>
                     <a:lstStyle/>
                     <a:p>
-                      <a:pPr indent="0" marL="0">
+                      <a:pPr marL="0" indent="0">
                         <a:buNone/>
                       </a:pPr>
                       <a:r>
@@ -3619,7 +3602,7 @@
                       </a:endParaRPr>
                     </a:p>
                   </a:txBody>
-                  <a:tcPr marL="91440" marR="91440" marT="45720" marB="45720" anchor="ctr">
+                  <a:tcPr anchor="ctr">
                     <a:lnL w="6350" cap="flat" cmpd="sng" algn="ctr">
                       <a:solidFill>
                         <a:srgbClr val="DCE7E9"/>
@@ -3663,7 +3646,7 @@
                     <a:bodyPr/>
                     <a:lstStyle/>
                     <a:p>
-                      <a:pPr indent="0" marL="0">
+                      <a:pPr marL="0" indent="0">
                         <a:buNone/>
                       </a:pPr>
                       <a:r>
@@ -3684,7 +3667,7 @@
                       </a:endParaRPr>
                     </a:p>
                   </a:txBody>
-                  <a:tcPr marL="91440" marR="91440" marT="45720" marB="45720" anchor="ctr">
+                  <a:tcPr anchor="ctr">
                     <a:lnL w="6350" cap="flat" cmpd="sng" algn="ctr">
                       <a:solidFill>
                         <a:srgbClr val="DCE7E9"/>
@@ -3723,6 +3706,11 @@
                     </a:lnB>
                   </a:tcPr>
                 </a:tc>
+                <a:extLst>
+                  <a:ext uri="{0D108BD9-81ED-4DB2-BD59-A6C34878D82A}">
+                    <a16:rowId xmlns:a16="http://schemas.microsoft.com/office/drawing/2014/main" val="10004"/>
+                  </a:ext>
+                </a:extLst>
               </a:tr>
               <a:tr h="548640">
                 <a:tc>
@@ -3730,7 +3718,7 @@
                     <a:bodyPr/>
                     <a:lstStyle/>
                     <a:p>
-                      <a:pPr indent="0" marL="0">
+                      <a:pPr marL="0" indent="0">
                         <a:buNone/>
                       </a:pPr>
                       <a:r>
@@ -3751,7 +3739,7 @@
                       </a:endParaRPr>
                     </a:p>
                   </a:txBody>
-                  <a:tcPr marL="91440" marR="91440" marT="45720" marB="45720" anchor="ctr">
+                  <a:tcPr anchor="ctr">
                     <a:lnL w="6350" cap="flat" cmpd="sng" algn="ctr">
                       <a:solidFill>
                         <a:srgbClr val="DCE7E9"/>
@@ -3795,7 +3783,7 @@
                     <a:bodyPr/>
                     <a:lstStyle/>
                     <a:p>
-                      <a:pPr indent="0" marL="0">
+                      <a:pPr marL="0" indent="0">
                         <a:buNone/>
                       </a:pPr>
                       <a:r>
@@ -3816,7 +3804,7 @@
                       </a:endParaRPr>
                     </a:p>
                   </a:txBody>
-                  <a:tcPr marL="91440" marR="91440" marT="45720" marB="45720" anchor="ctr">
+                  <a:tcPr anchor="ctr">
                     <a:lnL w="6350" cap="flat" cmpd="sng" algn="ctr">
                       <a:solidFill>
                         <a:srgbClr val="DCE7E9"/>
@@ -3855,6 +3843,11 @@
                     </a:lnB>
                   </a:tcPr>
                 </a:tc>
+                <a:extLst>
+                  <a:ext uri="{0D108BD9-81ED-4DB2-BD59-A6C34878D82A}">
+                    <a16:rowId xmlns:a16="http://schemas.microsoft.com/office/drawing/2014/main" val="10005"/>
+                  </a:ext>
+                </a:extLst>
               </a:tr>
             </a:tbl>
           </a:graphicData>
@@ -3881,7 +3874,7 @@
           <a:bodyPr wrap="square" rtlCol="0" anchor="ctr"/>
           <a:lstStyle/>
           <a:p>
-            <a:pPr indent="0" marL="0">
+            <a:pPr marL="0" indent="0">
               <a:buNone/>
             </a:pPr>
             <a:r>
@@ -3920,7 +3913,7 @@
           <a:bodyPr wrap="square" rtlCol="0" anchor="ctr"/>
           <a:lstStyle/>
           <a:p>
-            <a:pPr algn="r" indent="0" marL="0">
+            <a:pPr marL="0" indent="0" algn="r">
               <a:buNone/>
             </a:pPr>
             <a:r>
@@ -3954,6 +3947,7 @@
         <a:solidFill>
           <a:srgbClr val="0B1E33"/>
         </a:solidFill>
+        <a:effectLst/>
       </p:bgPr>
     </p:bg>
     <p:spTree>
@@ -3991,7 +3985,7 @@
           <a:bodyPr wrap="square" lIns="0" tIns="0" rIns="0" bIns="0" rtlCol="0" anchor="ctr"/>
           <a:lstStyle/>
           <a:p>
-            <a:pPr indent="0" marL="0">
+            <a:pPr marL="0" indent="0">
               <a:buNone/>
             </a:pPr>
             <a:r>
@@ -4030,7 +4024,7 @@
           <a:bodyPr wrap="square" lIns="0" tIns="0" rIns="0" bIns="0" rtlCol="0" anchor="ctr"/>
           <a:lstStyle/>
           <a:p>
-            <a:pPr indent="0" marL="0">
+            <a:pPr marL="0" indent="0">
               <a:buNone/>
             </a:pPr>
             <a:r>
@@ -4069,6 +4063,13 @@
           </a:solidFill>
           <a:ln/>
         </p:spPr>
+        <p:txBody>
+          <a:bodyPr/>
+          <a:lstStyle/>
+          <a:p>
+            <a:endParaRPr lang="en-UA"/>
+          </a:p>
+        </p:txBody>
       </p:sp>
       <p:sp>
         <p:nvSpPr>
@@ -4089,17 +4090,24 @@
           </a:solidFill>
           <a:ln/>
         </p:spPr>
+        <p:txBody>
+          <a:bodyPr/>
+          <a:lstStyle/>
+          <a:p>
+            <a:endParaRPr lang="en-UA"/>
+          </a:p>
+        </p:txBody>
       </p:sp>
       <p:pic>
         <p:nvPicPr>
-          <p:cNvPr id="6" name="Image 0" descr="preencoded.png">    </p:cNvPr>
+          <p:cNvPr id="6" name="Image 0" descr="preencoded.png"/>
           <p:cNvPicPr>
             <a:picLocks noChangeAspect="1"/>
           </p:cNvPicPr>
           <p:nvPr/>
         </p:nvPicPr>
         <p:blipFill>
-          <a:blip r:embed="rId1"/>
+          <a:blip r:embed="rId3"/>
           <a:stretch>
             <a:fillRect/>
           </a:stretch>
@@ -4135,7 +4143,7 @@
           <a:bodyPr wrap="square" lIns="0" tIns="0" rIns="0" bIns="0" rtlCol="0" anchor="ctr"/>
           <a:lstStyle/>
           <a:p>
-            <a:pPr indent="0" marL="0">
+            <a:pPr marL="0" indent="0">
               <a:buNone/>
             </a:pPr>
             <a:r>
@@ -4179,6 +4187,13 @@
             <a:prstDash val="solid"/>
           </a:ln>
         </p:spPr>
+        <p:txBody>
+          <a:bodyPr/>
+          <a:lstStyle/>
+          <a:p>
+            <a:endParaRPr lang="en-UA"/>
+          </a:p>
+        </p:txBody>
       </p:sp>
       <p:sp>
         <p:nvSpPr>
@@ -4199,6 +4214,13 @@
           </a:solidFill>
           <a:ln/>
         </p:spPr>
+        <p:txBody>
+          <a:bodyPr/>
+          <a:lstStyle/>
+          <a:p>
+            <a:endParaRPr lang="en-UA"/>
+          </a:p>
+        </p:txBody>
       </p:sp>
       <p:sp>
         <p:nvSpPr>
@@ -4219,6 +4241,13 @@
           </a:solidFill>
           <a:ln/>
         </p:spPr>
+        <p:txBody>
+          <a:bodyPr/>
+          <a:lstStyle/>
+          <a:p>
+            <a:endParaRPr lang="en-UA"/>
+          </a:p>
+        </p:txBody>
       </p:sp>
       <p:sp>
         <p:nvSpPr>
@@ -4239,6 +4268,13 @@
           </a:solidFill>
           <a:ln/>
         </p:spPr>
+        <p:txBody>
+          <a:bodyPr/>
+          <a:lstStyle/>
+          <a:p>
+            <a:endParaRPr lang="en-UA"/>
+          </a:p>
+        </p:txBody>
       </p:sp>
       <p:sp>
         <p:nvSpPr>
@@ -4261,7 +4297,7 @@
           <a:bodyPr wrap="square" lIns="0" tIns="0" rIns="0" bIns="0" rtlCol="0" anchor="t"/>
           <a:lstStyle/>
           <a:p>
-            <a:pPr indent="0" marL="0">
+            <a:pPr marL="0" indent="0">
               <a:lnSpc>
                 <a:spcPct val="115000"/>
               </a:lnSpc>
@@ -4281,7 +4317,7 @@
             <a:endParaRPr lang="en-US" sz="1300" dirty="0"/>
           </a:p>
           <a:p>
-            <a:pPr indent="0" marL="0">
+            <a:pPr marL="0" indent="0">
               <a:lnSpc>
                 <a:spcPct val="115000"/>
               </a:lnSpc>
@@ -4301,7 +4337,7 @@
             <a:endParaRPr lang="en-US" sz="1300" dirty="0"/>
           </a:p>
           <a:p>
-            <a:pPr indent="0" marL="0">
+            <a:pPr marL="0" indent="0">
               <a:lnSpc>
                 <a:spcPct val="115000"/>
               </a:lnSpc>
@@ -4321,7 +4357,7 @@
             <a:endParaRPr lang="en-US" sz="1300" dirty="0"/>
           </a:p>
           <a:p>
-            <a:pPr indent="0" marL="0">
+            <a:pPr marL="0" indent="0">
               <a:lnSpc>
                 <a:spcPct val="115000"/>
               </a:lnSpc>
@@ -4341,7 +4377,7 @@
             <a:endParaRPr lang="en-US" sz="1300" dirty="0"/>
           </a:p>
           <a:p>
-            <a:pPr indent="0" marL="0">
+            <a:pPr marL="0" indent="0">
               <a:lnSpc>
                 <a:spcPct val="115000"/>
               </a:lnSpc>
@@ -4383,6 +4419,13 @@
           </a:solidFill>
           <a:ln/>
         </p:spPr>
+        <p:txBody>
+          <a:bodyPr/>
+          <a:lstStyle/>
+          <a:p>
+            <a:endParaRPr lang="en-UA"/>
+          </a:p>
+        </p:txBody>
       </p:sp>
       <p:sp>
         <p:nvSpPr>
@@ -4403,17 +4446,24 @@
           </a:solidFill>
           <a:ln/>
         </p:spPr>
+        <p:txBody>
+          <a:bodyPr/>
+          <a:lstStyle/>
+          <a:p>
+            <a:endParaRPr lang="en-UA"/>
+          </a:p>
+        </p:txBody>
       </p:sp>
       <p:pic>
         <p:nvPicPr>
-          <p:cNvPr id="15" name="Image 1" descr="preencoded.png">    </p:cNvPr>
+          <p:cNvPr id="15" name="Image 1" descr="preencoded.png"/>
           <p:cNvPicPr>
             <a:picLocks noChangeAspect="1"/>
           </p:cNvPicPr>
           <p:nvPr/>
         </p:nvPicPr>
         <p:blipFill>
-          <a:blip r:embed="rId2"/>
+          <a:blip r:embed="rId4"/>
           <a:stretch>
             <a:fillRect/>
           </a:stretch>
@@ -4449,7 +4499,7 @@
           <a:bodyPr wrap="square" lIns="0" tIns="0" rIns="0" bIns="0" rtlCol="0" anchor="ctr"/>
           <a:lstStyle/>
           <a:p>
-            <a:pPr indent="0" marL="0">
+            <a:pPr marL="0" indent="0">
               <a:buNone/>
             </a:pPr>
             <a:r>
@@ -4493,6 +4543,13 @@
             <a:prstDash val="solid"/>
           </a:ln>
         </p:spPr>
+        <p:txBody>
+          <a:bodyPr/>
+          <a:lstStyle/>
+          <a:p>
+            <a:endParaRPr lang="en-UA"/>
+          </a:p>
+        </p:txBody>
       </p:sp>
       <p:sp>
         <p:nvSpPr>
@@ -4513,6 +4570,13 @@
           </a:solidFill>
           <a:ln/>
         </p:spPr>
+        <p:txBody>
+          <a:bodyPr/>
+          <a:lstStyle/>
+          <a:p>
+            <a:endParaRPr lang="en-UA"/>
+          </a:p>
+        </p:txBody>
       </p:sp>
       <p:sp>
         <p:nvSpPr>
@@ -4533,6 +4597,13 @@
           </a:solidFill>
           <a:ln/>
         </p:spPr>
+        <p:txBody>
+          <a:bodyPr/>
+          <a:lstStyle/>
+          <a:p>
+            <a:endParaRPr lang="en-UA"/>
+          </a:p>
+        </p:txBody>
       </p:sp>
       <p:sp>
         <p:nvSpPr>
@@ -4553,6 +4624,13 @@
           </a:solidFill>
           <a:ln/>
         </p:spPr>
+        <p:txBody>
+          <a:bodyPr/>
+          <a:lstStyle/>
+          <a:p>
+            <a:endParaRPr lang="en-UA"/>
+          </a:p>
+        </p:txBody>
       </p:sp>
       <p:sp>
         <p:nvSpPr>
@@ -4575,7 +4653,7 @@
           <a:bodyPr wrap="square" lIns="0" tIns="0" rIns="0" bIns="0" rtlCol="0" anchor="t"/>
           <a:lstStyle/>
           <a:p>
-            <a:pPr indent="0" marL="0">
+            <a:pPr marL="0" indent="0">
               <a:lnSpc>
                 <a:spcPct val="115000"/>
               </a:lnSpc>
@@ -4595,7 +4673,7 @@
             <a:endParaRPr lang="en-US" sz="1300" dirty="0"/>
           </a:p>
           <a:p>
-            <a:pPr indent="0" marL="0">
+            <a:pPr marL="0" indent="0">
               <a:lnSpc>
                 <a:spcPct val="115000"/>
               </a:lnSpc>
@@ -4615,7 +4693,7 @@
             <a:endParaRPr lang="en-US" sz="1300" dirty="0"/>
           </a:p>
           <a:p>
-            <a:pPr indent="0" marL="0">
+            <a:pPr marL="0" indent="0">
               <a:lnSpc>
                 <a:spcPct val="115000"/>
               </a:lnSpc>
@@ -4635,7 +4713,7 @@
             <a:endParaRPr lang="en-US" sz="1300" dirty="0"/>
           </a:p>
           <a:p>
-            <a:pPr indent="0" marL="0">
+            <a:pPr marL="0" indent="0">
               <a:lnSpc>
                 <a:spcPct val="115000"/>
               </a:lnSpc>
@@ -4644,7 +4722,7 @@
             <a:endParaRPr lang="en-US" sz="1300" dirty="0"/>
           </a:p>
           <a:p>
-            <a:pPr indent="0" marL="0">
+            <a:pPr marL="0" indent="0">
               <a:lnSpc>
                 <a:spcPct val="115000"/>
               </a:lnSpc>
@@ -4686,7 +4764,7 @@
           <a:bodyPr wrap="square" rtlCol="0" anchor="ctr"/>
           <a:lstStyle/>
           <a:p>
-            <a:pPr indent="0" marL="0">
+            <a:pPr marL="0" indent="0">
               <a:buNone/>
             </a:pPr>
             <a:r>
@@ -4725,7 +4803,7 @@
           <a:bodyPr wrap="square" rtlCol="0" anchor="ctr"/>
           <a:lstStyle/>
           <a:p>
-            <a:pPr algn="r" indent="0" marL="0">
+            <a:pPr marL="0" indent="0" algn="r">
               <a:buNone/>
             </a:pPr>
             <a:r>
@@ -4759,6 +4837,7 @@
         <a:solidFill>
           <a:srgbClr val="FFFFFF"/>
         </a:solidFill>
+        <a:effectLst/>
       </p:bgPr>
     </p:bg>
     <p:spTree>
@@ -4796,7 +4875,7 @@
           <a:bodyPr wrap="square" lIns="0" tIns="0" rIns="0" bIns="0" rtlCol="0" anchor="ctr"/>
           <a:lstStyle/>
           <a:p>
-            <a:pPr indent="0" marL="0">
+            <a:pPr marL="0" indent="0">
               <a:buNone/>
             </a:pPr>
             <a:r>
@@ -4835,7 +4914,7 @@
           <a:bodyPr wrap="square" lIns="0" tIns="0" rIns="0" bIns="0" rtlCol="0" anchor="ctr"/>
           <a:lstStyle/>
           <a:p>
-            <a:pPr indent="0" marL="0">
+            <a:pPr marL="0" indent="0">
               <a:buNone/>
             </a:pPr>
             <a:r>
@@ -4874,13 +4953,20 @@
           </a:solidFill>
           <a:ln/>
           <a:effectLst>
-            <a:outerShdw sx="100000" sy="100000" kx="0" ky="0" algn="bl" rotWithShape="0" blurRad="76200" dist="25400" dir="5400000">
+            <a:outerShdw blurRad="76200" dist="25400" dir="5400000" algn="bl" rotWithShape="0">
               <a:srgbClr val="0B1E33">
                 <a:alpha val="10000"/>
               </a:srgbClr>
             </a:outerShdw>
           </a:effectLst>
         </p:spPr>
+        <p:txBody>
+          <a:bodyPr/>
+          <a:lstStyle/>
+          <a:p>
+            <a:endParaRPr lang="en-UA"/>
+          </a:p>
+        </p:txBody>
       </p:sp>
       <p:sp>
         <p:nvSpPr>
@@ -4903,7 +4989,7 @@
           <a:bodyPr wrap="square" lIns="0" tIns="0" rIns="0" bIns="0" rtlCol="0" anchor="ctr"/>
           <a:lstStyle/>
           <a:p>
-            <a:pPr indent="0" marL="0">
+            <a:pPr marL="0" indent="0">
               <a:buNone/>
             </a:pPr>
             <a:r>
@@ -4942,7 +5028,7 @@
           <a:bodyPr wrap="square" lIns="0" tIns="0" rIns="0" bIns="0" rtlCol="0" anchor="t"/>
           <a:lstStyle/>
           <a:p>
-            <a:pPr indent="0" marL="0">
+            <a:pPr marL="0" indent="0">
               <a:buNone/>
             </a:pPr>
             <a:r>
@@ -4986,6 +5072,13 @@
             <a:prstDash val="solid"/>
           </a:ln>
         </p:spPr>
+        <p:txBody>
+          <a:bodyPr/>
+          <a:lstStyle/>
+          <a:p>
+            <a:endParaRPr lang="en-UA"/>
+          </a:p>
+        </p:txBody>
       </p:sp>
       <p:sp>
         <p:nvSpPr>
@@ -5006,6 +5099,13 @@
           </a:solidFill>
           <a:ln/>
         </p:spPr>
+        <p:txBody>
+          <a:bodyPr/>
+          <a:lstStyle/>
+          <a:p>
+            <a:endParaRPr lang="en-UA"/>
+          </a:p>
+        </p:txBody>
       </p:sp>
       <p:sp>
         <p:nvSpPr>
@@ -5026,6 +5126,13 @@
           </a:solidFill>
           <a:ln/>
         </p:spPr>
+        <p:txBody>
+          <a:bodyPr/>
+          <a:lstStyle/>
+          <a:p>
+            <a:endParaRPr lang="en-UA"/>
+          </a:p>
+        </p:txBody>
       </p:sp>
       <p:sp>
         <p:nvSpPr>
@@ -5046,6 +5153,13 @@
           </a:solidFill>
           <a:ln/>
         </p:spPr>
+        <p:txBody>
+          <a:bodyPr/>
+          <a:lstStyle/>
+          <a:p>
+            <a:endParaRPr lang="en-UA"/>
+          </a:p>
+        </p:txBody>
       </p:sp>
       <p:sp>
         <p:nvSpPr>
@@ -5068,7 +5182,7 @@
           <a:bodyPr wrap="square" lIns="0" tIns="0" rIns="0" bIns="0" rtlCol="0" anchor="t"/>
           <a:lstStyle/>
           <a:p>
-            <a:pPr indent="0" marL="0">
+            <a:pPr marL="0" indent="0">
               <a:lnSpc>
                 <a:spcPct val="115000"/>
               </a:lnSpc>
@@ -5088,7 +5202,7 @@
             <a:endParaRPr lang="en-US" sz="1150" dirty="0"/>
           </a:p>
           <a:p>
-            <a:pPr indent="0" marL="0">
+            <a:pPr marL="0" indent="0">
               <a:lnSpc>
                 <a:spcPct val="115000"/>
               </a:lnSpc>
@@ -5130,13 +5244,20 @@
           </a:solidFill>
           <a:ln/>
           <a:effectLst>
-            <a:outerShdw sx="100000" sy="100000" kx="0" ky="0" algn="bl" rotWithShape="0" blurRad="76200" dist="25400" dir="5400000">
+            <a:outerShdw blurRad="76200" dist="25400" dir="5400000" algn="bl" rotWithShape="0">
               <a:srgbClr val="0B1E33">
                 <a:alpha val="10000"/>
               </a:srgbClr>
             </a:outerShdw>
           </a:effectLst>
         </p:spPr>
+        <p:txBody>
+          <a:bodyPr/>
+          <a:lstStyle/>
+          <a:p>
+            <a:endParaRPr lang="en-UA"/>
+          </a:p>
+        </p:txBody>
       </p:sp>
       <p:sp>
         <p:nvSpPr>
@@ -5159,7 +5280,7 @@
           <a:bodyPr wrap="square" lIns="0" tIns="0" rIns="0" bIns="0" rtlCol="0" anchor="ctr"/>
           <a:lstStyle/>
           <a:p>
-            <a:pPr indent="0" marL="0">
+            <a:pPr marL="0" indent="0">
               <a:buNone/>
             </a:pPr>
             <a:r>
@@ -5198,7 +5319,7 @@
           <a:bodyPr wrap="square" lIns="0" tIns="0" rIns="0" bIns="0" rtlCol="0" anchor="t"/>
           <a:lstStyle/>
           <a:p>
-            <a:pPr indent="0" marL="0">
+            <a:pPr marL="0" indent="0">
               <a:buNone/>
             </a:pPr>
             <a:r>
@@ -5242,6 +5363,13 @@
             <a:prstDash val="solid"/>
           </a:ln>
         </p:spPr>
+        <p:txBody>
+          <a:bodyPr/>
+          <a:lstStyle/>
+          <a:p>
+            <a:endParaRPr lang="en-UA"/>
+          </a:p>
+        </p:txBody>
       </p:sp>
       <p:sp>
         <p:nvSpPr>
@@ -5262,6 +5390,13 @@
           </a:solidFill>
           <a:ln/>
         </p:spPr>
+        <p:txBody>
+          <a:bodyPr/>
+          <a:lstStyle/>
+          <a:p>
+            <a:endParaRPr lang="en-UA"/>
+          </a:p>
+        </p:txBody>
       </p:sp>
       <p:sp>
         <p:nvSpPr>
@@ -5282,6 +5417,13 @@
           </a:solidFill>
           <a:ln/>
         </p:spPr>
+        <p:txBody>
+          <a:bodyPr/>
+          <a:lstStyle/>
+          <a:p>
+            <a:endParaRPr lang="en-UA"/>
+          </a:p>
+        </p:txBody>
       </p:sp>
       <p:sp>
         <p:nvSpPr>
@@ -5302,6 +5444,13 @@
           </a:solidFill>
           <a:ln/>
         </p:spPr>
+        <p:txBody>
+          <a:bodyPr/>
+          <a:lstStyle/>
+          <a:p>
+            <a:endParaRPr lang="en-UA"/>
+          </a:p>
+        </p:txBody>
       </p:sp>
       <p:sp>
         <p:nvSpPr>
@@ -5324,7 +5473,7 @@
           <a:bodyPr wrap="square" lIns="0" tIns="0" rIns="0" bIns="0" rtlCol="0" anchor="t"/>
           <a:lstStyle/>
           <a:p>
-            <a:pPr indent="0" marL="0">
+            <a:pPr marL="0" indent="0">
               <a:lnSpc>
                 <a:spcPct val="115000"/>
               </a:lnSpc>
@@ -5344,7 +5493,7 @@
             <a:endParaRPr lang="en-US" sz="1150" dirty="0"/>
           </a:p>
           <a:p>
-            <a:pPr indent="0" marL="0">
+            <a:pPr marL="0" indent="0">
               <a:lnSpc>
                 <a:spcPct val="115000"/>
               </a:lnSpc>
@@ -5386,13 +5535,20 @@
           </a:solidFill>
           <a:ln/>
           <a:effectLst>
-            <a:outerShdw sx="100000" sy="100000" kx="0" ky="0" algn="bl" rotWithShape="0" blurRad="76200" dist="25400" dir="5400000">
+            <a:outerShdw blurRad="76200" dist="25400" dir="5400000" algn="bl" rotWithShape="0">
               <a:srgbClr val="0B1E33">
                 <a:alpha val="10000"/>
               </a:srgbClr>
             </a:outerShdw>
           </a:effectLst>
         </p:spPr>
+        <p:txBody>
+          <a:bodyPr/>
+          <a:lstStyle/>
+          <a:p>
+            <a:endParaRPr lang="en-UA"/>
+          </a:p>
+        </p:txBody>
       </p:sp>
       <p:sp>
         <p:nvSpPr>
@@ -5415,7 +5571,7 @@
           <a:bodyPr wrap="square" lIns="0" tIns="0" rIns="0" bIns="0" rtlCol="0" anchor="ctr"/>
           <a:lstStyle/>
           <a:p>
-            <a:pPr indent="0" marL="0">
+            <a:pPr marL="0" indent="0">
               <a:buNone/>
             </a:pPr>
             <a:r>
@@ -5454,7 +5610,7 @@
           <a:bodyPr wrap="square" lIns="0" tIns="0" rIns="0" bIns="0" rtlCol="0" anchor="t"/>
           <a:lstStyle/>
           <a:p>
-            <a:pPr indent="0" marL="0">
+            <a:pPr marL="0" indent="0">
               <a:buNone/>
             </a:pPr>
             <a:r>
@@ -5498,6 +5654,13 @@
             <a:prstDash val="solid"/>
           </a:ln>
         </p:spPr>
+        <p:txBody>
+          <a:bodyPr/>
+          <a:lstStyle/>
+          <a:p>
+            <a:endParaRPr lang="en-UA"/>
+          </a:p>
+        </p:txBody>
       </p:sp>
       <p:sp>
         <p:nvSpPr>
@@ -5518,6 +5681,13 @@
           </a:solidFill>
           <a:ln/>
         </p:spPr>
+        <p:txBody>
+          <a:bodyPr/>
+          <a:lstStyle/>
+          <a:p>
+            <a:endParaRPr lang="en-UA"/>
+          </a:p>
+        </p:txBody>
       </p:sp>
       <p:sp>
         <p:nvSpPr>
@@ -5538,6 +5708,13 @@
           </a:solidFill>
           <a:ln/>
         </p:spPr>
+        <p:txBody>
+          <a:bodyPr/>
+          <a:lstStyle/>
+          <a:p>
+            <a:endParaRPr lang="en-UA"/>
+          </a:p>
+        </p:txBody>
       </p:sp>
       <p:sp>
         <p:nvSpPr>
@@ -5558,6 +5735,13 @@
           </a:solidFill>
           <a:ln/>
         </p:spPr>
+        <p:txBody>
+          <a:bodyPr/>
+          <a:lstStyle/>
+          <a:p>
+            <a:endParaRPr lang="en-UA"/>
+          </a:p>
+        </p:txBody>
       </p:sp>
       <p:sp>
         <p:nvSpPr>
@@ -5580,7 +5764,7 @@
           <a:bodyPr wrap="square" lIns="0" tIns="0" rIns="0" bIns="0" rtlCol="0" anchor="t"/>
           <a:lstStyle/>
           <a:p>
-            <a:pPr indent="0" marL="0">
+            <a:pPr marL="0" indent="0">
               <a:lnSpc>
                 <a:spcPct val="115000"/>
               </a:lnSpc>
@@ -5600,7 +5784,7 @@
             <a:endParaRPr lang="en-US" sz="1150" dirty="0"/>
           </a:p>
           <a:p>
-            <a:pPr indent="0" marL="0">
+            <a:pPr marL="0" indent="0">
               <a:lnSpc>
                 <a:spcPct val="115000"/>
               </a:lnSpc>
@@ -5620,7 +5804,7 @@
             <a:endParaRPr lang="en-US" sz="1150" dirty="0"/>
           </a:p>
           <a:p>
-            <a:pPr indent="0" marL="0">
+            <a:pPr marL="0" indent="0">
               <a:lnSpc>
                 <a:spcPct val="115000"/>
               </a:lnSpc>
@@ -5662,7 +5846,7 @@
           <a:bodyPr wrap="square" rtlCol="0" anchor="ctr"/>
           <a:lstStyle/>
           <a:p>
-            <a:pPr indent="0" marL="0">
+            <a:pPr marL="0" indent="0">
               <a:buNone/>
             </a:pPr>
             <a:r>
@@ -5701,7 +5885,7 @@
           <a:bodyPr wrap="square" rtlCol="0" anchor="ctr"/>
           <a:lstStyle/>
           <a:p>
-            <a:pPr algn="r" indent="0" marL="0">
+            <a:pPr marL="0" indent="0" algn="r">
               <a:buNone/>
             </a:pPr>
             <a:r>
@@ -5735,6 +5919,7 @@
         <a:solidFill>
           <a:srgbClr val="EAF4F6"/>
         </a:solidFill>
+        <a:effectLst/>
       </p:bgPr>
     </p:bg>
     <p:spTree>
@@ -5772,7 +5957,7 @@
           <a:bodyPr wrap="square" lIns="0" tIns="0" rIns="0" bIns="0" rtlCol="0" anchor="ctr"/>
           <a:lstStyle/>
           <a:p>
-            <a:pPr indent="0" marL="0">
+            <a:pPr marL="0" indent="0">
               <a:buNone/>
             </a:pPr>
             <a:r>
@@ -5811,7 +5996,7 @@
           <a:bodyPr wrap="square" lIns="0" tIns="0" rIns="0" bIns="0" rtlCol="0" anchor="ctr"/>
           <a:lstStyle/>
           <a:p>
-            <a:pPr indent="0" marL="0">
+            <a:pPr marL="0" indent="0">
               <a:buNone/>
             </a:pPr>
             <a:r>
@@ -5855,6 +6040,13 @@
             <a:prstDash val="solid"/>
           </a:ln>
         </p:spPr>
+        <p:txBody>
+          <a:bodyPr/>
+          <a:lstStyle/>
+          <a:p>
+            <a:endParaRPr lang="en-UA"/>
+          </a:p>
+        </p:txBody>
       </p:sp>
       <p:sp>
         <p:nvSpPr>
@@ -5875,6 +6067,13 @@
           </a:solidFill>
           <a:ln/>
         </p:spPr>
+        <p:txBody>
+          <a:bodyPr/>
+          <a:lstStyle/>
+          <a:p>
+            <a:endParaRPr lang="en-UA"/>
+          </a:p>
+        </p:txBody>
       </p:sp>
       <p:sp>
         <p:nvSpPr>
@@ -5895,6 +6094,13 @@
           </a:solidFill>
           <a:ln/>
         </p:spPr>
+        <p:txBody>
+          <a:bodyPr/>
+          <a:lstStyle/>
+          <a:p>
+            <a:endParaRPr lang="en-UA"/>
+          </a:p>
+        </p:txBody>
       </p:sp>
       <p:sp>
         <p:nvSpPr>
@@ -5915,6 +6121,13 @@
           </a:solidFill>
           <a:ln/>
         </p:spPr>
+        <p:txBody>
+          <a:bodyPr/>
+          <a:lstStyle/>
+          <a:p>
+            <a:endParaRPr lang="en-UA"/>
+          </a:p>
+        </p:txBody>
       </p:sp>
       <p:sp>
         <p:nvSpPr>
@@ -5937,7 +6150,7 @@
           <a:bodyPr wrap="square" lIns="0" tIns="0" rIns="0" bIns="0" rtlCol="0" anchor="t"/>
           <a:lstStyle/>
           <a:p>
-            <a:pPr indent="0" marL="0">
+            <a:pPr marL="0" indent="0">
               <a:lnSpc>
                 <a:spcPct val="115000"/>
               </a:lnSpc>
@@ -5957,7 +6170,7 @@
             <a:endParaRPr lang="en-US" sz="1350" dirty="0"/>
           </a:p>
           <a:p>
-            <a:pPr indent="0" marL="0">
+            <a:pPr marL="0" indent="0">
               <a:lnSpc>
                 <a:spcPct val="115000"/>
               </a:lnSpc>
@@ -5977,7 +6190,7 @@
             <a:endParaRPr lang="en-US" sz="1350" dirty="0"/>
           </a:p>
           <a:p>
-            <a:pPr indent="0" marL="0">
+            <a:pPr marL="0" indent="0">
               <a:lnSpc>
                 <a:spcPct val="115000"/>
               </a:lnSpc>
@@ -5997,7 +6210,7 @@
             <a:endParaRPr lang="en-US" sz="1350" dirty="0"/>
           </a:p>
           <a:p>
-            <a:pPr indent="0" marL="0">
+            <a:pPr marL="0" indent="0">
               <a:lnSpc>
                 <a:spcPct val="115000"/>
               </a:lnSpc>
@@ -6006,7 +6219,7 @@
             <a:endParaRPr lang="en-US" sz="1350" dirty="0"/>
           </a:p>
           <a:p>
-            <a:pPr indent="0" marL="0">
+            <a:pPr marL="0" indent="0">
               <a:lnSpc>
                 <a:spcPct val="115000"/>
               </a:lnSpc>
@@ -6026,7 +6239,7 @@
             <a:endParaRPr lang="en-US" sz="1350" dirty="0"/>
           </a:p>
           <a:p>
-            <a:pPr indent="0" marL="0">
+            <a:pPr marL="0" indent="0">
               <a:lnSpc>
                 <a:spcPct val="115000"/>
               </a:lnSpc>
@@ -6046,7 +6259,7 @@
             <a:endParaRPr lang="en-US" sz="1350" dirty="0"/>
           </a:p>
           <a:p>
-            <a:pPr indent="0" marL="0">
+            <a:pPr marL="0" indent="0">
               <a:lnSpc>
                 <a:spcPct val="115000"/>
               </a:lnSpc>
@@ -6088,13 +6301,20 @@
           </a:solidFill>
           <a:ln/>
           <a:effectLst>
-            <a:outerShdw sx="100000" sy="100000" kx="0" ky="0" algn="bl" rotWithShape="0" blurRad="76200" dist="25400" dir="5400000">
+            <a:outerShdw blurRad="76200" dist="25400" dir="5400000" algn="bl" rotWithShape="0">
               <a:srgbClr val="0B1E33">
                 <a:alpha val="10000"/>
               </a:srgbClr>
             </a:outerShdw>
           </a:effectLst>
         </p:spPr>
+        <p:txBody>
+          <a:bodyPr/>
+          <a:lstStyle/>
+          <a:p>
+            <a:endParaRPr lang="en-UA"/>
+          </a:p>
+        </p:txBody>
       </p:sp>
       <p:sp>
         <p:nvSpPr>
@@ -6115,17 +6335,24 @@
           </a:solidFill>
           <a:ln/>
         </p:spPr>
+        <p:txBody>
+          <a:bodyPr/>
+          <a:lstStyle/>
+          <a:p>
+            <a:endParaRPr lang="en-UA"/>
+          </a:p>
+        </p:txBody>
       </p:sp>
       <p:pic>
         <p:nvPicPr>
-          <p:cNvPr id="11" name="Image 0" descr="preencoded.png">    </p:cNvPr>
+          <p:cNvPr id="11" name="Image 0" descr="preencoded.png"/>
           <p:cNvPicPr>
             <a:picLocks noChangeAspect="1"/>
           </p:cNvPicPr>
           <p:nvPr/>
         </p:nvPicPr>
         <p:blipFill>
-          <a:blip r:embed="rId1"/>
+          <a:blip r:embed="rId3"/>
           <a:stretch>
             <a:fillRect/>
           </a:stretch>
@@ -6161,7 +6388,7 @@
           <a:bodyPr wrap="square" lIns="0" tIns="0" rIns="0" bIns="0" rtlCol="0" anchor="ctr"/>
           <a:lstStyle/>
           <a:p>
-            <a:pPr indent="0" marL="0">
+            <a:pPr marL="0" indent="0">
               <a:buNone/>
             </a:pPr>
             <a:r>
@@ -6200,7 +6427,7 @@
           <a:bodyPr wrap="square" lIns="0" tIns="0" rIns="0" bIns="0" rtlCol="0" anchor="t"/>
           <a:lstStyle/>
           <a:p>
-            <a:pPr indent="0" marL="0">
+            <a:pPr marL="0" indent="0">
               <a:buNone/>
             </a:pPr>
             <a:r>
@@ -6239,13 +6466,20 @@
           </a:solidFill>
           <a:ln/>
           <a:effectLst>
-            <a:outerShdw sx="100000" sy="100000" kx="0" ky="0" algn="bl" rotWithShape="0" blurRad="76200" dist="25400" dir="5400000">
+            <a:outerShdw blurRad="76200" dist="25400" dir="5400000" algn="bl" rotWithShape="0">
               <a:srgbClr val="0B1E33">
                 <a:alpha val="10000"/>
               </a:srgbClr>
             </a:outerShdw>
           </a:effectLst>
         </p:spPr>
+        <p:txBody>
+          <a:bodyPr/>
+          <a:lstStyle/>
+          <a:p>
+            <a:endParaRPr lang="en-UA"/>
+          </a:p>
+        </p:txBody>
       </p:sp>
       <p:sp>
         <p:nvSpPr>
@@ -6266,17 +6500,24 @@
           </a:solidFill>
           <a:ln/>
         </p:spPr>
+        <p:txBody>
+          <a:bodyPr/>
+          <a:lstStyle/>
+          <a:p>
+            <a:endParaRPr lang="en-UA"/>
+          </a:p>
+        </p:txBody>
       </p:sp>
       <p:pic>
         <p:nvPicPr>
-          <p:cNvPr id="16" name="Image 1" descr="preencoded.png">    </p:cNvPr>
+          <p:cNvPr id="16" name="Image 1" descr="preencoded.png"/>
           <p:cNvPicPr>
             <a:picLocks noChangeAspect="1"/>
           </p:cNvPicPr>
           <p:nvPr/>
         </p:nvPicPr>
         <p:blipFill>
-          <a:blip r:embed="rId2"/>
+          <a:blip r:embed="rId4"/>
           <a:stretch>
             <a:fillRect/>
           </a:stretch>
@@ -6312,7 +6553,7 @@
           <a:bodyPr wrap="square" lIns="0" tIns="0" rIns="0" bIns="0" rtlCol="0" anchor="ctr"/>
           <a:lstStyle/>
           <a:p>
-            <a:pPr indent="0" marL="0">
+            <a:pPr marL="0" indent="0">
               <a:buNone/>
             </a:pPr>
             <a:r>
@@ -6351,7 +6592,7 @@
           <a:bodyPr wrap="square" lIns="0" tIns="0" rIns="0" bIns="0" rtlCol="0" anchor="t"/>
           <a:lstStyle/>
           <a:p>
-            <a:pPr indent="0" marL="0">
+            <a:pPr marL="0" indent="0">
               <a:buNone/>
             </a:pPr>
             <a:r>
@@ -6390,7 +6631,7 @@
           <a:bodyPr wrap="square" rtlCol="0" anchor="ctr"/>
           <a:lstStyle/>
           <a:p>
-            <a:pPr indent="0" marL="0">
+            <a:pPr marL="0" indent="0">
               <a:buNone/>
             </a:pPr>
             <a:r>
@@ -6429,7 +6670,7 @@
           <a:bodyPr wrap="square" rtlCol="0" anchor="ctr"/>
           <a:lstStyle/>
           <a:p>
-            <a:pPr algn="r" indent="0" marL="0">
+            <a:pPr marL="0" indent="0" algn="r">
               <a:buNone/>
             </a:pPr>
             <a:r>
@@ -6463,6 +6704,7 @@
         <a:solidFill>
           <a:srgbClr val="FFFFFF"/>
         </a:solidFill>
+        <a:effectLst/>
       </p:bgPr>
     </p:bg>
     <p:spTree>
@@ -6500,11 +6742,11 @@
           <a:bodyPr wrap="square" lIns="0" tIns="0" rIns="0" bIns="0" rtlCol="0" anchor="ctr"/>
           <a:lstStyle/>
           <a:p>
-            <a:pPr indent="0" marL="0">
-              <a:buNone/>
-            </a:pPr>
-            <a:r>
-              <a:rPr lang="en-US" sz="3200" b="1" dirty="0">
+            <a:pPr marL="0" indent="0">
+              <a:buNone/>
+            </a:pPr>
+            <a:r>
+              <a:rPr lang="uk-UA" sz="3200" b="1" dirty="0">
                 <a:solidFill>
                   <a:srgbClr val="0B1E33"/>
                 </a:solidFill>
@@ -6512,7 +6754,18 @@
                 <a:ea typeface="Bookman Old Style" pitchFamily="34" charset="-122"/>
                 <a:cs typeface="Bookman Old Style" pitchFamily="34" charset="-120"/>
               </a:rPr>
-              <a:t>Практика: робота з CSV-файлами</a:t>
+              <a:t>Робота</a:t>
+            </a:r>
+            <a:r>
+              <a:rPr lang="en-US" sz="3200" b="1" dirty="0">
+                <a:solidFill>
+                  <a:srgbClr val="0B1E33"/>
+                </a:solidFill>
+                <a:latin typeface="Bookman Old Style" pitchFamily="34" charset="0"/>
+                <a:ea typeface="Bookman Old Style" pitchFamily="34" charset="-122"/>
+                <a:cs typeface="Bookman Old Style" pitchFamily="34" charset="-120"/>
+              </a:rPr>
+              <a:t> з CSV-файлами</a:t>
             </a:r>
             <a:endParaRPr lang="en-US" sz="3200" dirty="0"/>
           </a:p>
@@ -6539,7 +6792,7 @@
           <a:bodyPr wrap="square" lIns="0" tIns="0" rIns="0" bIns="0" rtlCol="0" anchor="ctr"/>
           <a:lstStyle/>
           <a:p>
-            <a:pPr indent="0" marL="0">
+            <a:pPr marL="0" indent="0">
               <a:buNone/>
             </a:pPr>
             <a:r>
@@ -6583,6 +6836,13 @@
             <a:prstDash val="solid"/>
           </a:ln>
         </p:spPr>
+        <p:txBody>
+          <a:bodyPr/>
+          <a:lstStyle/>
+          <a:p>
+            <a:endParaRPr lang="en-UA"/>
+          </a:p>
+        </p:txBody>
       </p:sp>
       <p:sp>
         <p:nvSpPr>
@@ -6603,6 +6863,13 @@
           </a:solidFill>
           <a:ln/>
         </p:spPr>
+        <p:txBody>
+          <a:bodyPr/>
+          <a:lstStyle/>
+          <a:p>
+            <a:endParaRPr lang="en-UA"/>
+          </a:p>
+        </p:txBody>
       </p:sp>
       <p:sp>
         <p:nvSpPr>
@@ -6623,6 +6890,13 @@
           </a:solidFill>
           <a:ln/>
         </p:spPr>
+        <p:txBody>
+          <a:bodyPr/>
+          <a:lstStyle/>
+          <a:p>
+            <a:endParaRPr lang="en-UA"/>
+          </a:p>
+        </p:txBody>
       </p:sp>
       <p:sp>
         <p:nvSpPr>
@@ -6643,6 +6917,13 @@
           </a:solidFill>
           <a:ln/>
         </p:spPr>
+        <p:txBody>
+          <a:bodyPr/>
+          <a:lstStyle/>
+          <a:p>
+            <a:endParaRPr lang="en-UA"/>
+          </a:p>
+        </p:txBody>
       </p:sp>
       <p:sp>
         <p:nvSpPr>
@@ -6665,7 +6946,7 @@
           <a:bodyPr wrap="square" lIns="0" tIns="0" rIns="0" bIns="0" rtlCol="0" anchor="t"/>
           <a:lstStyle/>
           <a:p>
-            <a:pPr indent="0" marL="0">
+            <a:pPr marL="0" indent="0">
               <a:lnSpc>
                 <a:spcPct val="115000"/>
               </a:lnSpc>
@@ -6685,7 +6966,7 @@
             <a:endParaRPr lang="en-US" sz="1350" dirty="0"/>
           </a:p>
           <a:p>
-            <a:pPr indent="0" marL="0">
+            <a:pPr marL="0" indent="0">
               <a:lnSpc>
                 <a:spcPct val="115000"/>
               </a:lnSpc>
@@ -6694,7 +6975,7 @@
             <a:endParaRPr lang="en-US" sz="1350" dirty="0"/>
           </a:p>
           <a:p>
-            <a:pPr indent="0" marL="0">
+            <a:pPr marL="0" indent="0">
               <a:lnSpc>
                 <a:spcPct val="115000"/>
               </a:lnSpc>
@@ -6714,7 +6995,7 @@
             <a:endParaRPr lang="en-US" sz="1350" dirty="0"/>
           </a:p>
           <a:p>
-            <a:pPr indent="0" marL="0">
+            <a:pPr marL="0" indent="0">
               <a:lnSpc>
                 <a:spcPct val="115000"/>
               </a:lnSpc>
@@ -6734,7 +7015,7 @@
             <a:endParaRPr lang="en-US" sz="1350" dirty="0"/>
           </a:p>
           <a:p>
-            <a:pPr indent="0" marL="0">
+            <a:pPr marL="0" indent="0">
               <a:lnSpc>
                 <a:spcPct val="115000"/>
               </a:lnSpc>
@@ -6754,7 +7035,7 @@
             <a:endParaRPr lang="en-US" sz="1350" dirty="0"/>
           </a:p>
           <a:p>
-            <a:pPr indent="0" marL="0">
+            <a:pPr marL="0" indent="0">
               <a:lnSpc>
                 <a:spcPct val="115000"/>
               </a:lnSpc>
@@ -6774,7 +7055,7 @@
             <a:endParaRPr lang="en-US" sz="1350" dirty="0"/>
           </a:p>
           <a:p>
-            <a:pPr indent="0" marL="0">
+            <a:pPr marL="0" indent="0">
               <a:lnSpc>
                 <a:spcPct val="115000"/>
               </a:lnSpc>
@@ -6816,7 +7097,7 @@
           <a:bodyPr wrap="square" lIns="0" tIns="0" rIns="0" bIns="0" rtlCol="0" anchor="ctr"/>
           <a:lstStyle/>
           <a:p>
-            <a:pPr indent="0" marL="0">
+            <a:pPr marL="0" indent="0">
               <a:buNone/>
             </a:pPr>
             <a:r>
@@ -6836,7 +7117,7 @@
       </p:sp>
       <p:graphicFrame>
         <p:nvGraphicFramePr>
-          <p:cNvPr id="8" name="Table 0"/>
+          <p:cNvPr id="10" name="Table 0"/>
           <p:cNvGraphicFramePr>
             <a:graphicFrameLocks noGrp="1"/>
           </p:cNvGraphicFramePr>
@@ -6850,15 +7131,27 @@
         </p:nvGraphicFramePr>
         <p:xfrm>
           <a:off x="6766560" y="2331720"/>
-          <a:ext cx="4297680" cy="914400"/>
+          <a:ext cx="4297680" cy="1691640"/>
         </p:xfrm>
         <a:graphic>
           <a:graphicData uri="http://schemas.openxmlformats.org/drawingml/2006/table">
             <a:tbl>
               <a:tblPr/>
               <a:tblGrid>
-                <a:gridCol w="2148840"/>
-                <a:gridCol w="2148840"/>
+                <a:gridCol w="2148840">
+                  <a:extLst>
+                    <a:ext uri="{9D8B030D-6E8A-4147-A177-3AD203B41FA5}">
+                      <a16:colId xmlns:a16="http://schemas.microsoft.com/office/drawing/2014/main" val="20000"/>
+                    </a:ext>
+                  </a:extLst>
+                </a:gridCol>
+                <a:gridCol w="2148840">
+                  <a:extLst>
+                    <a:ext uri="{9D8B030D-6E8A-4147-A177-3AD203B41FA5}">
+                      <a16:colId xmlns:a16="http://schemas.microsoft.com/office/drawing/2014/main" val="20001"/>
+                    </a:ext>
+                  </a:extLst>
+                </a:gridCol>
               </a:tblGrid>
               <a:tr h="457200">
                 <a:tc>
@@ -6866,7 +7159,7 @@
                     <a:bodyPr/>
                     <a:lstStyle/>
                     <a:p>
-                      <a:pPr indent="0" marL="0">
+                      <a:pPr marL="0" indent="0">
                         <a:buNone/>
                       </a:pPr>
                       <a:r>
@@ -6887,7 +7180,7 @@
                       </a:endParaRPr>
                     </a:p>
                   </a:txBody>
-                  <a:tcPr marL="91440" marR="91440" marT="45720" marB="45720" anchor="ctr">
+                  <a:tcPr anchor="ctr">
                     <a:lnL w="6350" cap="flat" cmpd="sng" algn="ctr">
                       <a:solidFill>
                         <a:srgbClr val="DCE7E9"/>
@@ -6934,7 +7227,7 @@
                     <a:bodyPr/>
                     <a:lstStyle/>
                     <a:p>
-                      <a:pPr indent="0" marL="0">
+                      <a:pPr marL="0" indent="0">
                         <a:buNone/>
                       </a:pPr>
                       <a:r>
@@ -6955,7 +7248,7 @@
                       </a:endParaRPr>
                     </a:p>
                   </a:txBody>
-                  <a:tcPr marL="91440" marR="91440" marT="45720" marB="45720" anchor="ctr">
+                  <a:tcPr anchor="ctr">
                     <a:lnL w="6350" cap="flat" cmpd="sng" algn="ctr">
                       <a:solidFill>
                         <a:srgbClr val="DCE7E9"/>
@@ -6997,6 +7290,11 @@
                     </a:solidFill>
                   </a:tcPr>
                 </a:tc>
+                <a:extLst>
+                  <a:ext uri="{0D108BD9-81ED-4DB2-BD59-A6C34878D82A}">
+                    <a16:rowId xmlns:a16="http://schemas.microsoft.com/office/drawing/2014/main" val="10000"/>
+                  </a:ext>
+                </a:extLst>
               </a:tr>
               <a:tr h="411480">
                 <a:tc>
@@ -7004,7 +7302,7 @@
                     <a:bodyPr/>
                     <a:lstStyle/>
                     <a:p>
-                      <a:pPr indent="0" marL="0">
+                      <a:pPr marL="0" indent="0">
                         <a:buNone/>
                       </a:pPr>
                       <a:r>
@@ -7025,7 +7323,7 @@
                       </a:endParaRPr>
                     </a:p>
                   </a:txBody>
-                  <a:tcPr marL="91440" marR="91440" marT="45720" marB="45720" anchor="ctr">
+                  <a:tcPr anchor="ctr">
                     <a:lnL w="6350" cap="flat" cmpd="sng" algn="ctr">
                       <a:solidFill>
                         <a:srgbClr val="DCE7E9"/>
@@ -7069,7 +7367,7 @@
                     <a:bodyPr/>
                     <a:lstStyle/>
                     <a:p>
-                      <a:pPr indent="0" marL="0">
+                      <a:pPr marL="0" indent="0">
                         <a:buNone/>
                       </a:pPr>
                       <a:r>
@@ -7090,7 +7388,7 @@
                       </a:endParaRPr>
                     </a:p>
                   </a:txBody>
-                  <a:tcPr marL="91440" marR="91440" marT="45720" marB="45720" anchor="ctr">
+                  <a:tcPr anchor="ctr">
                     <a:lnL w="6350" cap="flat" cmpd="sng" algn="ctr">
                       <a:solidFill>
                         <a:srgbClr val="DCE7E9"/>
@@ -7129,6 +7427,11 @@
                     </a:lnB>
                   </a:tcPr>
                 </a:tc>
+                <a:extLst>
+                  <a:ext uri="{0D108BD9-81ED-4DB2-BD59-A6C34878D82A}">
+                    <a16:rowId xmlns:a16="http://schemas.microsoft.com/office/drawing/2014/main" val="10001"/>
+                  </a:ext>
+                </a:extLst>
               </a:tr>
               <a:tr h="411480">
                 <a:tc>
@@ -7136,7 +7439,7 @@
                     <a:bodyPr/>
                     <a:lstStyle/>
                     <a:p>
-                      <a:pPr indent="0" marL="0">
+                      <a:pPr marL="0" indent="0">
                         <a:buNone/>
                       </a:pPr>
                       <a:r>
@@ -7157,7 +7460,7 @@
                       </a:endParaRPr>
                     </a:p>
                   </a:txBody>
-                  <a:tcPr marL="91440" marR="91440" marT="45720" marB="45720" anchor="ctr">
+                  <a:tcPr anchor="ctr">
                     <a:lnL w="6350" cap="flat" cmpd="sng" algn="ctr">
                       <a:solidFill>
                         <a:srgbClr val="DCE7E9"/>
@@ -7201,7 +7504,7 @@
                     <a:bodyPr/>
                     <a:lstStyle/>
                     <a:p>
-                      <a:pPr indent="0" marL="0">
+                      <a:pPr marL="0" indent="0">
                         <a:buNone/>
                       </a:pPr>
                       <a:r>
@@ -7222,7 +7525,7 @@
                       </a:endParaRPr>
                     </a:p>
                   </a:txBody>
-                  <a:tcPr marL="91440" marR="91440" marT="45720" marB="45720" anchor="ctr">
+                  <a:tcPr anchor="ctr">
                     <a:lnL w="6350" cap="flat" cmpd="sng" algn="ctr">
                       <a:solidFill>
                         <a:srgbClr val="DCE7E9"/>
@@ -7261,6 +7564,11 @@
                     </a:lnB>
                   </a:tcPr>
                 </a:tc>
+                <a:extLst>
+                  <a:ext uri="{0D108BD9-81ED-4DB2-BD59-A6C34878D82A}">
+                    <a16:rowId xmlns:a16="http://schemas.microsoft.com/office/drawing/2014/main" val="10002"/>
+                  </a:ext>
+                </a:extLst>
               </a:tr>
               <a:tr h="411480">
                 <a:tc>
@@ -7268,7 +7576,7 @@
                     <a:bodyPr/>
                     <a:lstStyle/>
                     <a:p>
-                      <a:pPr indent="0" marL="0">
+                      <a:pPr marL="0" indent="0">
                         <a:buNone/>
                       </a:pPr>
                       <a:r>
@@ -7289,7 +7597,7 @@
                       </a:endParaRPr>
                     </a:p>
                   </a:txBody>
-                  <a:tcPr marL="91440" marR="91440" marT="45720" marB="45720" anchor="ctr">
+                  <a:tcPr anchor="ctr">
                     <a:lnL w="6350" cap="flat" cmpd="sng" algn="ctr">
                       <a:solidFill>
                         <a:srgbClr val="DCE7E9"/>
@@ -7333,7 +7641,7 @@
                     <a:bodyPr/>
                     <a:lstStyle/>
                     <a:p>
-                      <a:pPr indent="0" marL="0">
+                      <a:pPr marL="0" indent="0">
                         <a:buNone/>
                       </a:pPr>
                       <a:r>
@@ -7354,7 +7662,7 @@
                       </a:endParaRPr>
                     </a:p>
                   </a:txBody>
-                  <a:tcPr marL="91440" marR="91440" marT="45720" marB="45720" anchor="ctr">
+                  <a:tcPr anchor="ctr">
                     <a:lnL w="6350" cap="flat" cmpd="sng" algn="ctr">
                       <a:solidFill>
                         <a:srgbClr val="DCE7E9"/>
@@ -7393,6 +7701,11 @@
                     </a:lnB>
                   </a:tcPr>
                 </a:tc>
+                <a:extLst>
+                  <a:ext uri="{0D108BD9-81ED-4DB2-BD59-A6C34878D82A}">
+                    <a16:rowId xmlns:a16="http://schemas.microsoft.com/office/drawing/2014/main" val="10003"/>
+                  </a:ext>
+                </a:extLst>
               </a:tr>
             </a:tbl>
           </a:graphicData>
@@ -7419,6 +7732,13 @@
           </a:solidFill>
           <a:ln/>
         </p:spPr>
+        <p:txBody>
+          <a:bodyPr/>
+          <a:lstStyle/>
+          <a:p>
+            <a:endParaRPr lang="en-UA"/>
+          </a:p>
+        </p:txBody>
       </p:sp>
       <p:sp>
         <p:nvSpPr>
@@ -7439,17 +7759,24 @@
           </a:solidFill>
           <a:ln/>
         </p:spPr>
+        <p:txBody>
+          <a:bodyPr/>
+          <a:lstStyle/>
+          <a:p>
+            <a:endParaRPr lang="en-UA"/>
+          </a:p>
+        </p:txBody>
       </p:sp>
       <p:pic>
         <p:nvPicPr>
-          <p:cNvPr id="13" name="Image 0" descr="preencoded.png">    </p:cNvPr>
+          <p:cNvPr id="13" name="Image 0" descr="preencoded.png"/>
           <p:cNvPicPr>
             <a:picLocks noChangeAspect="1"/>
           </p:cNvPicPr>
           <p:nvPr/>
         </p:nvPicPr>
         <p:blipFill>
-          <a:blip r:embed="rId1"/>
+          <a:blip r:embed="rId3"/>
           <a:stretch>
             <a:fillRect/>
           </a:stretch>
@@ -7485,7 +7812,7 @@
           <a:bodyPr wrap="square" lIns="0" tIns="0" rIns="0" bIns="0" rtlCol="0" anchor="ctr"/>
           <a:lstStyle/>
           <a:p>
-            <a:pPr indent="0" marL="0">
+            <a:pPr marL="0" indent="0">
               <a:buNone/>
             </a:pPr>
             <a:r>
@@ -7524,7 +7851,7 @@
           <a:bodyPr wrap="square" rtlCol="0" anchor="ctr"/>
           <a:lstStyle/>
           <a:p>
-            <a:pPr indent="0" marL="0">
+            <a:pPr marL="0" indent="0">
               <a:buNone/>
             </a:pPr>
             <a:r>
@@ -7563,7 +7890,7 @@
           <a:bodyPr wrap="square" rtlCol="0" anchor="ctr"/>
           <a:lstStyle/>
           <a:p>
-            <a:pPr algn="r" indent="0" marL="0">
+            <a:pPr marL="0" indent="0" algn="r">
               <a:buNone/>
             </a:pPr>
             <a:r>
@@ -7597,6 +7924,7 @@
         <a:solidFill>
           <a:srgbClr val="0B1E33"/>
         </a:solidFill>
+        <a:effectLst/>
       </p:bgPr>
     </p:bg>
     <p:spTree>
@@ -7634,7 +7962,7 @@
           <a:bodyPr wrap="square" lIns="0" tIns="0" rIns="0" bIns="0" rtlCol="0" anchor="ctr"/>
           <a:lstStyle/>
           <a:p>
-            <a:pPr indent="0" marL="0">
+            <a:pPr marL="0" indent="0">
               <a:buNone/>
             </a:pPr>
             <a:r>
@@ -7673,7 +8001,7 @@
           <a:bodyPr wrap="square" lIns="0" tIns="0" rIns="0" bIns="0" rtlCol="0" anchor="ctr"/>
           <a:lstStyle/>
           <a:p>
-            <a:pPr indent="0" marL="0">
+            <a:pPr marL="0" indent="0">
               <a:buNone/>
             </a:pPr>
             <a:r>
@@ -7717,6 +8045,13 @@
             <a:prstDash val="solid"/>
           </a:ln>
         </p:spPr>
+        <p:txBody>
+          <a:bodyPr/>
+          <a:lstStyle/>
+          <a:p>
+            <a:endParaRPr lang="en-UA"/>
+          </a:p>
+        </p:txBody>
       </p:sp>
       <p:sp>
         <p:nvSpPr>
@@ -7737,6 +8072,13 @@
           </a:solidFill>
           <a:ln/>
         </p:spPr>
+        <p:txBody>
+          <a:bodyPr/>
+          <a:lstStyle/>
+          <a:p>
+            <a:endParaRPr lang="en-UA"/>
+          </a:p>
+        </p:txBody>
       </p:sp>
       <p:sp>
         <p:nvSpPr>
@@ -7757,6 +8099,13 @@
           </a:solidFill>
           <a:ln/>
         </p:spPr>
+        <p:txBody>
+          <a:bodyPr/>
+          <a:lstStyle/>
+          <a:p>
+            <a:endParaRPr lang="en-UA"/>
+          </a:p>
+        </p:txBody>
       </p:sp>
       <p:sp>
         <p:nvSpPr>
@@ -7777,6 +8126,13 @@
           </a:solidFill>
           <a:ln/>
         </p:spPr>
+        <p:txBody>
+          <a:bodyPr/>
+          <a:lstStyle/>
+          <a:p>
+            <a:endParaRPr lang="en-UA"/>
+          </a:p>
+        </p:txBody>
       </p:sp>
       <p:sp>
         <p:nvSpPr>
@@ -7799,7 +8155,7 @@
           <a:bodyPr wrap="square" lIns="0" tIns="0" rIns="0" bIns="0" rtlCol="0" anchor="t"/>
           <a:lstStyle/>
           <a:p>
-            <a:pPr indent="0" marL="0">
+            <a:pPr marL="0" indent="0">
               <a:lnSpc>
                 <a:spcPct val="115000"/>
               </a:lnSpc>
@@ -7819,7 +8175,7 @@
             <a:endParaRPr lang="en-US" sz="1350" dirty="0"/>
           </a:p>
           <a:p>
-            <a:pPr indent="0" marL="0">
+            <a:pPr marL="0" indent="0">
               <a:lnSpc>
                 <a:spcPct val="115000"/>
               </a:lnSpc>
@@ -7839,7 +8195,7 @@
             <a:endParaRPr lang="en-US" sz="1350" dirty="0"/>
           </a:p>
           <a:p>
-            <a:pPr indent="0" marL="0">
+            <a:pPr marL="0" indent="0">
               <a:lnSpc>
                 <a:spcPct val="115000"/>
               </a:lnSpc>
@@ -7859,7 +8215,7 @@
             <a:endParaRPr lang="en-US" sz="1350" dirty="0"/>
           </a:p>
           <a:p>
-            <a:pPr indent="0" marL="0">
+            <a:pPr marL="0" indent="0">
               <a:lnSpc>
                 <a:spcPct val="115000"/>
               </a:lnSpc>
@@ -7879,7 +8235,7 @@
             <a:endParaRPr lang="en-US" sz="1350" dirty="0"/>
           </a:p>
           <a:p>
-            <a:pPr indent="0" marL="0">
+            <a:pPr marL="0" indent="0">
               <a:lnSpc>
                 <a:spcPct val="115000"/>
               </a:lnSpc>
@@ -7899,7 +8255,7 @@
             <a:endParaRPr lang="en-US" sz="1350" dirty="0"/>
           </a:p>
           <a:p>
-            <a:pPr indent="0" marL="0">
+            <a:pPr marL="0" indent="0">
               <a:lnSpc>
                 <a:spcPct val="115000"/>
               </a:lnSpc>
@@ -7919,7 +8275,7 @@
             <a:endParaRPr lang="en-US" sz="1350" dirty="0"/>
           </a:p>
           <a:p>
-            <a:pPr indent="0" marL="0">
+            <a:pPr marL="0" indent="0">
               <a:lnSpc>
                 <a:spcPct val="115000"/>
               </a:lnSpc>
@@ -7959,176 +8315,17 @@
           </a:solidFill>
           <a:ln/>
         </p:spPr>
+        <p:txBody>
+          <a:bodyPr/>
+          <a:lstStyle/>
+          <a:p>
+            <a:endParaRPr lang="en-UA"/>
+          </a:p>
+        </p:txBody>
       </p:sp>
       <p:pic>
         <p:nvPicPr>
-          <p:cNvPr id="10" name="Image 0" descr="preencoded.png">    </p:cNvPr>
-          <p:cNvPicPr>
-            <a:picLocks noChangeAspect="1"/>
-          </p:cNvPicPr>
-          <p:nvPr/>
-        </p:nvPicPr>
-        <p:blipFill>
-          <a:blip r:embed="rId1"/>
-          <a:stretch>
-            <a:fillRect/>
-          </a:stretch>
-        </p:blipFill>
-        <p:spPr>
-          <a:xfrm>
-            <a:off x="6993788" y="2330348"/>
-            <a:ext cx="231343" cy="231343"/>
-          </a:xfrm>
-          <a:prstGeom prst="rect">
-            <a:avLst/>
-          </a:prstGeom>
-        </p:spPr>
-      </p:pic>
-      <p:sp>
-        <p:nvSpPr>
-          <p:cNvPr id="11" name="Text 8"/>
-          <p:cNvSpPr/>
-          <p:nvPr/>
-        </p:nvSpPr>
-        <p:spPr>
-          <a:xfrm>
-            <a:off x="7543800" y="2194560"/>
-            <a:ext cx="4206240" cy="822960"/>
-          </a:xfrm>
-          <a:prstGeom prst="rect">
-            <a:avLst/>
-          </a:prstGeom>
-          <a:noFill/>
-          <a:ln/>
-        </p:spPr>
-        <p:txBody>
-          <a:bodyPr wrap="square" lIns="0" tIns="0" rIns="0" bIns="0" rtlCol="0" anchor="ctr"/>
-          <a:lstStyle/>
-          <a:p>
-            <a:pPr indent="0" marL="0">
-              <a:buNone/>
-            </a:pPr>
-            <a:r>
-              <a:rPr lang="en-US" sz="1300" dirty="0">
-                <a:solidFill>
-                  <a:srgbClr val="DCEEF0"/>
-                </a:solidFill>
-                <a:latin typeface="Calibri" pitchFamily="34" charset="0"/>
-                <a:ea typeface="Calibri" pitchFamily="34" charset="-122"/>
-                <a:cs typeface="Calibri" pitchFamily="34" charset="-120"/>
-              </a:rPr>
-              <a:t>FileNotFoundError — файл не існує за вказаним шляхом</a:t>
-            </a:r>
-            <a:endParaRPr lang="en-US" sz="1300" dirty="0"/>
-          </a:p>
-        </p:txBody>
-      </p:sp>
-      <p:sp>
-        <p:nvSpPr>
-          <p:cNvPr id="12" name="Shape 9"/>
-          <p:cNvSpPr/>
-          <p:nvPr/>
-        </p:nvSpPr>
-        <p:spPr>
-          <a:xfrm>
-            <a:off x="6858000" y="3246120"/>
-            <a:ext cx="502920" cy="502920"/>
-          </a:xfrm>
-          <a:prstGeom prst="ellipse">
-            <a:avLst/>
-          </a:prstGeom>
-          <a:solidFill>
-            <a:srgbClr val="0E3A52"/>
-          </a:solidFill>
-          <a:ln/>
-        </p:spPr>
-      </p:sp>
-      <p:pic>
-        <p:nvPicPr>
-          <p:cNvPr id="13" name="Image 1" descr="preencoded.png">    </p:cNvPr>
-          <p:cNvPicPr>
-            <a:picLocks noChangeAspect="1"/>
-          </p:cNvPicPr>
-          <p:nvPr/>
-        </p:nvPicPr>
-        <p:blipFill>
-          <a:blip r:embed="rId2"/>
-          <a:stretch>
-            <a:fillRect/>
-          </a:stretch>
-        </p:blipFill>
-        <p:spPr>
-          <a:xfrm>
-            <a:off x="6993788" y="3381908"/>
-            <a:ext cx="231343" cy="231343"/>
-          </a:xfrm>
-          <a:prstGeom prst="rect">
-            <a:avLst/>
-          </a:prstGeom>
-        </p:spPr>
-      </p:pic>
-      <p:sp>
-        <p:nvSpPr>
-          <p:cNvPr id="14" name="Text 10"/>
-          <p:cNvSpPr/>
-          <p:nvPr/>
-        </p:nvSpPr>
-        <p:spPr>
-          <a:xfrm>
-            <a:off x="7543800" y="3246120"/>
-            <a:ext cx="4206240" cy="822960"/>
-          </a:xfrm>
-          <a:prstGeom prst="rect">
-            <a:avLst/>
-          </a:prstGeom>
-          <a:noFill/>
-          <a:ln/>
-        </p:spPr>
-        <p:txBody>
-          <a:bodyPr wrap="square" lIns="0" tIns="0" rIns="0" bIns="0" rtlCol="0" anchor="ctr"/>
-          <a:lstStyle/>
-          <a:p>
-            <a:pPr indent="0" marL="0">
-              <a:buNone/>
-            </a:pPr>
-            <a:r>
-              <a:rPr lang="en-US" sz="1300" dirty="0">
-                <a:solidFill>
-                  <a:srgbClr val="DCEEF0"/>
-                </a:solidFill>
-                <a:latin typeface="Calibri" pitchFamily="34" charset="0"/>
-                <a:ea typeface="Calibri" pitchFamily="34" charset="-122"/>
-                <a:cs typeface="Calibri" pitchFamily="34" charset="-120"/>
-              </a:rPr>
-              <a:t>PermissionError — недостатньо прав доступу</a:t>
-            </a:r>
-            <a:endParaRPr lang="en-US" sz="1300" dirty="0"/>
-          </a:p>
-        </p:txBody>
-      </p:sp>
-      <p:sp>
-        <p:nvSpPr>
-          <p:cNvPr id="15" name="Shape 11"/>
-          <p:cNvSpPr/>
-          <p:nvPr/>
-        </p:nvSpPr>
-        <p:spPr>
-          <a:xfrm>
-            <a:off x="6858000" y="4297680"/>
-            <a:ext cx="502920" cy="502920"/>
-          </a:xfrm>
-          <a:prstGeom prst="ellipse">
-            <a:avLst/>
-          </a:prstGeom>
-          <a:solidFill>
-            <a:srgbClr val="0E3A52"/>
-          </a:solidFill>
-          <a:ln/>
-        </p:spPr>
-      </p:sp>
-      <p:pic>
-        <p:nvPicPr>
-          <p:cNvPr id="16" name="Image 2" descr="preencoded.png">    </p:cNvPr>
+          <p:cNvPr id="10" name="Image 0" descr="preencoded.png"/>
           <p:cNvPicPr>
             <a:picLocks noChangeAspect="1"/>
           </p:cNvPicPr>
@@ -8142,7 +8339,7 @@
         </p:blipFill>
         <p:spPr>
           <a:xfrm>
-            <a:off x="6993788" y="4433468"/>
+            <a:off x="6993788" y="2330348"/>
             <a:ext cx="231343" cy="231343"/>
           </a:xfrm>
           <a:prstGeom prst="rect">
@@ -8152,13 +8349,13 @@
       </p:pic>
       <p:sp>
         <p:nvSpPr>
-          <p:cNvPr id="17" name="Text 12"/>
-          <p:cNvSpPr/>
-          <p:nvPr/>
-        </p:nvSpPr>
-        <p:spPr>
-          <a:xfrm>
-            <a:off x="7543800" y="4297680"/>
+          <p:cNvPr id="11" name="Text 8"/>
+          <p:cNvSpPr/>
+          <p:nvPr/>
+        </p:nvSpPr>
+        <p:spPr>
+          <a:xfrm>
+            <a:off x="7543800" y="2194560"/>
             <a:ext cx="4206240" cy="822960"/>
           </a:xfrm>
           <a:prstGeom prst="rect">
@@ -8171,7 +8368,7 @@
           <a:bodyPr wrap="square" lIns="0" tIns="0" rIns="0" bIns="0" rtlCol="0" anchor="ctr"/>
           <a:lstStyle/>
           <a:p>
-            <a:pPr indent="0" marL="0">
+            <a:pPr marL="0" indent="0">
               <a:buNone/>
             </a:pPr>
             <a:r>
@@ -8183,7 +8380,7 @@
                 <a:ea typeface="Calibri" pitchFamily="34" charset="-122"/>
                 <a:cs typeface="Calibri" pitchFamily="34" charset="-120"/>
               </a:rPr>
-              <a:t>finally — код, що виконається в будь-якому разі</a:t>
+              <a:t>FileNotFoundError — файл не існує за вказаним шляхом</a:t>
             </a:r>
             <a:endParaRPr lang="en-US" sz="1300" dirty="0"/>
           </a:p>
@@ -8191,37 +8388,217 @@
       </p:sp>
       <p:sp>
         <p:nvSpPr>
-          <p:cNvPr id="18" name="Text 13"/>
-          <p:cNvSpPr/>
-          <p:nvPr/>
-        </p:nvSpPr>
-        <p:spPr>
-          <a:xfrm>
-            <a:off x="457200" y="6473952"/>
-            <a:ext cx="5486400" cy="274320"/>
+          <p:cNvPr id="12" name="Shape 9"/>
+          <p:cNvSpPr/>
+          <p:nvPr/>
+        </p:nvSpPr>
+        <p:spPr>
+          <a:xfrm>
+            <a:off x="6858000" y="3246120"/>
+            <a:ext cx="502920" cy="502920"/>
+          </a:xfrm>
+          <a:prstGeom prst="ellipse">
+            <a:avLst/>
+          </a:prstGeom>
+          <a:solidFill>
+            <a:srgbClr val="0E3A52"/>
+          </a:solidFill>
+          <a:ln/>
+        </p:spPr>
+        <p:txBody>
+          <a:bodyPr/>
+          <a:lstStyle/>
+          <a:p>
+            <a:endParaRPr lang="en-UA"/>
+          </a:p>
+        </p:txBody>
+      </p:sp>
+      <p:pic>
+        <p:nvPicPr>
+          <p:cNvPr id="13" name="Image 1" descr="preencoded.png"/>
+          <p:cNvPicPr>
+            <a:picLocks noChangeAspect="1"/>
+          </p:cNvPicPr>
+          <p:nvPr/>
+        </p:nvPicPr>
+        <p:blipFill>
+          <a:blip r:embed="rId4"/>
+          <a:stretch>
+            <a:fillRect/>
+          </a:stretch>
+        </p:blipFill>
+        <p:spPr>
+          <a:xfrm>
+            <a:off x="6993788" y="3381908"/>
+            <a:ext cx="231343" cy="231343"/>
           </a:xfrm>
           <a:prstGeom prst="rect">
             <a:avLst/>
           </a:prstGeom>
+        </p:spPr>
+      </p:pic>
+      <p:sp>
+        <p:nvSpPr>
+          <p:cNvPr id="14" name="Text 10"/>
+          <p:cNvSpPr/>
+          <p:nvPr/>
+        </p:nvSpPr>
+        <p:spPr>
+          <a:xfrm>
+            <a:off x="7543800" y="3246120"/>
+            <a:ext cx="4206240" cy="822960"/>
+          </a:xfrm>
+          <a:prstGeom prst="rect">
+            <a:avLst/>
+          </a:prstGeom>
           <a:noFill/>
           <a:ln/>
         </p:spPr>
         <p:txBody>
-          <a:bodyPr wrap="square" rtlCol="0" anchor="ctr"/>
-          <a:lstStyle/>
-          <a:p>
-            <a:pPr indent="0" marL="0">
-              <a:buNone/>
-            </a:pPr>
-            <a:r>
-              <a:rPr lang="en-US" sz="1000" dirty="0">
-                <a:solidFill>
-                  <a:srgbClr val="8FA6AE"/>
+          <a:bodyPr wrap="square" lIns="0" tIns="0" rIns="0" bIns="0" rtlCol="0" anchor="ctr"/>
+          <a:lstStyle/>
+          <a:p>
+            <a:pPr marL="0" indent="0">
+              <a:buNone/>
+            </a:pPr>
+            <a:r>
+              <a:rPr lang="en-US" sz="1300" dirty="0">
+                <a:solidFill>
+                  <a:srgbClr val="DCEEF0"/>
                 </a:solidFill>
                 <a:latin typeface="Calibri" pitchFamily="34" charset="0"/>
                 <a:ea typeface="Calibri" pitchFamily="34" charset="-122"/>
                 <a:cs typeface="Calibri" pitchFamily="34" charset="-120"/>
               </a:rPr>
+              <a:t>PermissionError — недостатньо прав доступу</a:t>
+            </a:r>
+            <a:endParaRPr lang="en-US" sz="1300" dirty="0"/>
+          </a:p>
+        </p:txBody>
+      </p:sp>
+      <p:sp>
+        <p:nvSpPr>
+          <p:cNvPr id="15" name="Shape 11"/>
+          <p:cNvSpPr/>
+          <p:nvPr/>
+        </p:nvSpPr>
+        <p:spPr>
+          <a:xfrm>
+            <a:off x="6858000" y="4297680"/>
+            <a:ext cx="502920" cy="502920"/>
+          </a:xfrm>
+          <a:prstGeom prst="ellipse">
+            <a:avLst/>
+          </a:prstGeom>
+          <a:solidFill>
+            <a:srgbClr val="0E3A52"/>
+          </a:solidFill>
+          <a:ln/>
+        </p:spPr>
+        <p:txBody>
+          <a:bodyPr/>
+          <a:lstStyle/>
+          <a:p>
+            <a:endParaRPr lang="en-UA"/>
+          </a:p>
+        </p:txBody>
+      </p:sp>
+      <p:pic>
+        <p:nvPicPr>
+          <p:cNvPr id="16" name="Image 2" descr="preencoded.png"/>
+          <p:cNvPicPr>
+            <a:picLocks noChangeAspect="1"/>
+          </p:cNvPicPr>
+          <p:nvPr/>
+        </p:nvPicPr>
+        <p:blipFill>
+          <a:blip r:embed="rId5"/>
+          <a:stretch>
+            <a:fillRect/>
+          </a:stretch>
+        </p:blipFill>
+        <p:spPr>
+          <a:xfrm>
+            <a:off x="6993788" y="4433468"/>
+            <a:ext cx="231343" cy="231343"/>
+          </a:xfrm>
+          <a:prstGeom prst="rect">
+            <a:avLst/>
+          </a:prstGeom>
+        </p:spPr>
+      </p:pic>
+      <p:sp>
+        <p:nvSpPr>
+          <p:cNvPr id="17" name="Text 12"/>
+          <p:cNvSpPr/>
+          <p:nvPr/>
+        </p:nvSpPr>
+        <p:spPr>
+          <a:xfrm>
+            <a:off x="7543800" y="4297680"/>
+            <a:ext cx="4206240" cy="822960"/>
+          </a:xfrm>
+          <a:prstGeom prst="rect">
+            <a:avLst/>
+          </a:prstGeom>
+          <a:noFill/>
+          <a:ln/>
+        </p:spPr>
+        <p:txBody>
+          <a:bodyPr wrap="square" lIns="0" tIns="0" rIns="0" bIns="0" rtlCol="0" anchor="ctr"/>
+          <a:lstStyle/>
+          <a:p>
+            <a:pPr marL="0" indent="0">
+              <a:buNone/>
+            </a:pPr>
+            <a:r>
+              <a:rPr lang="en-US" sz="1300" dirty="0">
+                <a:solidFill>
+                  <a:srgbClr val="DCEEF0"/>
+                </a:solidFill>
+                <a:latin typeface="Calibri" pitchFamily="34" charset="0"/>
+                <a:ea typeface="Calibri" pitchFamily="34" charset="-122"/>
+                <a:cs typeface="Calibri" pitchFamily="34" charset="-120"/>
+              </a:rPr>
+              <a:t>finally — код, що виконається в будь-якому разі</a:t>
+            </a:r>
+            <a:endParaRPr lang="en-US" sz="1300" dirty="0"/>
+          </a:p>
+        </p:txBody>
+      </p:sp>
+      <p:sp>
+        <p:nvSpPr>
+          <p:cNvPr id="18" name="Text 13"/>
+          <p:cNvSpPr/>
+          <p:nvPr/>
+        </p:nvSpPr>
+        <p:spPr>
+          <a:xfrm>
+            <a:off x="457200" y="6473952"/>
+            <a:ext cx="5486400" cy="274320"/>
+          </a:xfrm>
+          <a:prstGeom prst="rect">
+            <a:avLst/>
+          </a:prstGeom>
+          <a:noFill/>
+          <a:ln/>
+        </p:spPr>
+        <p:txBody>
+          <a:bodyPr wrap="square" rtlCol="0" anchor="ctr"/>
+          <a:lstStyle/>
+          <a:p>
+            <a:pPr marL="0" indent="0">
+              <a:buNone/>
+            </a:pPr>
+            <a:r>
+              <a:rPr lang="en-US" sz="1000" dirty="0">
+                <a:solidFill>
+                  <a:srgbClr val="8FA6AE"/>
+                </a:solidFill>
+                <a:latin typeface="Calibri" pitchFamily="34" charset="0"/>
+                <a:ea typeface="Calibri" pitchFamily="34" charset="-122"/>
+                <a:cs typeface="Calibri" pitchFamily="34" charset="-120"/>
+              </a:rPr>
               <a:t>Python: робота з файлами</a:t>
             </a:r>
             <a:endParaRPr lang="en-US" sz="1000" dirty="0"/>
@@ -8249,7 +8626,7 @@
           <a:bodyPr wrap="square" rtlCol="0" anchor="ctr"/>
           <a:lstStyle/>
           <a:p>
-            <a:pPr algn="r" indent="0" marL="0">
+            <a:pPr marL="0" indent="0" algn="r">
               <a:buNone/>
             </a:pPr>
             <a:r>
@@ -8283,6 +8660,7 @@
         <a:solidFill>
           <a:srgbClr val="EAF4F6"/>
         </a:solidFill>
+        <a:effectLst/>
       </p:bgPr>
     </p:bg>
     <p:spTree>
@@ -8320,7 +8698,7 @@
           <a:bodyPr wrap="square" lIns="0" tIns="0" rIns="0" bIns="0" rtlCol="0" anchor="ctr"/>
           <a:lstStyle/>
           <a:p>
-            <a:pPr indent="0" marL="0">
+            <a:pPr marL="0" indent="0">
               <a:buNone/>
             </a:pPr>
             <a:r>
@@ -8359,13 +8737,20 @@
           </a:solidFill>
           <a:ln/>
           <a:effectLst>
-            <a:outerShdw sx="100000" sy="100000" kx="0" ky="0" algn="bl" rotWithShape="0" blurRad="101600" dist="38100" dir="5400000">
+            <a:outerShdw blurRad="101600" dist="38100" dir="5400000" algn="bl" rotWithShape="0">
               <a:srgbClr val="0B1E33">
                 <a:alpha val="12000"/>
               </a:srgbClr>
             </a:outerShdw>
           </a:effectLst>
         </p:spPr>
+        <p:txBody>
+          <a:bodyPr/>
+          <a:lstStyle/>
+          <a:p>
+            <a:endParaRPr lang="en-UA"/>
+          </a:p>
+        </p:txBody>
       </p:sp>
       <p:sp>
         <p:nvSpPr>
@@ -8388,7 +8773,7 @@
           <a:bodyPr wrap="square" lIns="0" tIns="0" rIns="0" bIns="0" rtlCol="0" anchor="ctr"/>
           <a:lstStyle/>
           <a:p>
-            <a:pPr indent="0" marL="0">
+            <a:pPr marL="0" indent="0">
               <a:buNone/>
             </a:pPr>
             <a:r>
@@ -8414,8 +8799,8 @@
         </p:nvSpPr>
         <p:spPr>
           <a:xfrm>
-            <a:off x="914400" y="2194560"/>
-            <a:ext cx="4663440" cy="3566160"/>
+            <a:off x="868680" y="2103120"/>
+            <a:ext cx="4663440" cy="2778238"/>
           </a:xfrm>
           <a:prstGeom prst="rect">
             <a:avLst/>
@@ -8575,13 +8960,20 @@
           </a:solidFill>
           <a:ln/>
           <a:effectLst>
-            <a:outerShdw sx="100000" sy="100000" kx="0" ky="0" algn="bl" rotWithShape="0" blurRad="101600" dist="38100" dir="5400000">
+            <a:outerShdw blurRad="101600" dist="38100" dir="5400000" algn="bl" rotWithShape="0">
               <a:srgbClr val="0B1E33">
                 <a:alpha val="12000"/>
               </a:srgbClr>
             </a:outerShdw>
           </a:effectLst>
         </p:spPr>
+        <p:txBody>
+          <a:bodyPr/>
+          <a:lstStyle/>
+          <a:p>
+            <a:endParaRPr lang="en-UA"/>
+          </a:p>
+        </p:txBody>
       </p:sp>
       <p:sp>
         <p:nvSpPr>
@@ -8602,17 +8994,24 @@
           </a:solidFill>
           <a:ln/>
         </p:spPr>
+        <p:txBody>
+          <a:bodyPr/>
+          <a:lstStyle/>
+          <a:p>
+            <a:endParaRPr lang="en-UA"/>
+          </a:p>
+        </p:txBody>
       </p:sp>
       <p:pic>
         <p:nvPicPr>
-          <p:cNvPr id="8" name="Image 0" descr="preencoded.png">    </p:cNvPr>
+          <p:cNvPr id="8" name="Image 0" descr="preencoded.png"/>
           <p:cNvPicPr>
             <a:picLocks noChangeAspect="1"/>
           </p:cNvPicPr>
           <p:nvPr/>
         </p:nvPicPr>
         <p:blipFill>
-          <a:blip r:embed="rId1"/>
+          <a:blip r:embed="rId3"/>
           <a:stretch>
             <a:fillRect/>
           </a:stretch>
@@ -8648,7 +9047,7 @@
           <a:bodyPr wrap="square" lIns="0" tIns="0" rIns="0" bIns="0" rtlCol="0" anchor="ctr"/>
           <a:lstStyle/>
           <a:p>
-            <a:pPr indent="0" marL="0">
+            <a:pPr marL="0" indent="0">
               <a:buNone/>
             </a:pPr>
             <a:r>
@@ -8687,7 +9086,7 @@
           <a:bodyPr wrap="square" lIns="0" tIns="0" rIns="0" bIns="0" rtlCol="0" anchor="t"/>
           <a:lstStyle/>
           <a:p>
-            <a:pPr indent="0" marL="0">
+            <a:pPr marL="0" indent="0">
               <a:buNone/>
             </a:pPr>
             <a:r>
@@ -8726,6 +9125,13 @@
           </a:solidFill>
           <a:ln/>
         </p:spPr>
+        <p:txBody>
+          <a:bodyPr/>
+          <a:lstStyle/>
+          <a:p>
+            <a:endParaRPr lang="en-UA"/>
+          </a:p>
+        </p:txBody>
       </p:sp>
       <p:sp>
         <p:nvSpPr>
@@ -8748,7 +9154,7 @@
           <a:bodyPr wrap="square" lIns="0" tIns="0" rIns="0" bIns="0" rtlCol="0" anchor="ctr"/>
           <a:lstStyle/>
           <a:p>
-            <a:pPr indent="0" marL="0">
+            <a:pPr marL="0" indent="0">
               <a:buNone/>
             </a:pPr>
             <a:r>
@@ -8787,7 +9193,7 @@
           <a:bodyPr wrap="square" lIns="0" tIns="0" rIns="0" bIns="0" rtlCol="0" anchor="t"/>
           <a:lstStyle/>
           <a:p>
-            <a:pPr indent="0" marL="0">
+            <a:pPr marL="0" indent="0">
               <a:buNone/>
             </a:pPr>
             <a:r>
@@ -8826,7 +9232,7 @@
           <a:bodyPr wrap="square" rtlCol="0" anchor="ctr"/>
           <a:lstStyle/>
           <a:p>
-            <a:pPr indent="0" marL="0">
+            <a:pPr marL="0" indent="0">
               <a:buNone/>
             </a:pPr>
             <a:r>
@@ -8865,7 +9271,7 @@
           <a:bodyPr wrap="square" rtlCol="0" anchor="ctr"/>
           <a:lstStyle/>
           <a:p>
-            <a:pPr algn="r" indent="0" marL="0">
+            <a:pPr marL="0" indent="0" algn="r">
               <a:buNone/>
             </a:pPr>
             <a:r>
@@ -9184,4 +9590,319 @@
     </a:ext>
   </a:extLst>
 </a:theme>
+</file>
+
+<file path=ppt/theme/theme2.xml><?xml version="1.0" encoding="utf-8"?>
+<a:theme xmlns:a="http://schemas.openxmlformats.org/drawingml/2006/main" name="Office Theme">
+  <a:themeElements>
+    <a:clrScheme name="Office">
+      <a:dk1>
+        <a:sysClr val="windowText" lastClr="000000"/>
+      </a:dk1>
+      <a:lt1>
+        <a:sysClr val="window" lastClr="FFFFFF"/>
+      </a:lt1>
+      <a:dk2>
+        <a:srgbClr val="0E2841"/>
+      </a:dk2>
+      <a:lt2>
+        <a:srgbClr val="E8E8E8"/>
+      </a:lt2>
+      <a:accent1>
+        <a:srgbClr val="156082"/>
+      </a:accent1>
+      <a:accent2>
+        <a:srgbClr val="E97132"/>
+      </a:accent2>
+      <a:accent3>
+        <a:srgbClr val="196B24"/>
+      </a:accent3>
+      <a:accent4>
+        <a:srgbClr val="0F9ED5"/>
+      </a:accent4>
+      <a:accent5>
+        <a:srgbClr val="A02B93"/>
+      </a:accent5>
+      <a:accent6>
+        <a:srgbClr val="4EA72E"/>
+      </a:accent6>
+      <a:hlink>
+        <a:srgbClr val="467886"/>
+      </a:hlink>
+      <a:folHlink>
+        <a:srgbClr val="96607D"/>
+      </a:folHlink>
+    </a:clrScheme>
+    <a:fontScheme name="Office">
+      <a:majorFont>
+        <a:latin typeface="Aptos Display" panose="02110004020202020204"/>
+        <a:ea typeface=""/>
+        <a:cs typeface=""/>
+        <a:font script="Jpan" typeface="游ゴシック Light"/>
+        <a:font script="Hang" typeface="맑은 고딕"/>
+        <a:font script="Hans" typeface="等线 Light"/>
+        <a:font script="Hant" typeface="新細明體"/>
+        <a:font script="Arab" typeface="Times New Roman"/>
+        <a:font script="Hebr" typeface="Times New Roman"/>
+        <a:font script="Thai" typeface="Angsana New"/>
+        <a:font script="Ethi" typeface="Nyala"/>
+        <a:font script="Beng" typeface="Vrinda"/>
+        <a:font script="Gujr" typeface="Shruti"/>
+        <a:font script="Khmr" typeface="MoolBoran"/>
+        <a:font script="Knda" typeface="Tunga"/>
+        <a:font script="Guru" typeface="Raavi"/>
+        <a:font script="Cans" typeface="Euphemia"/>
+        <a:font script="Cher" typeface="Plantagenet Cherokee"/>
+        <a:font script="Yiii" typeface="Microsoft Yi Baiti"/>
+        <a:font script="Tibt" typeface="Microsoft Himalaya"/>
+        <a:font script="Thaa" typeface="MV Boli"/>
+        <a:font script="Deva" typeface="Mangal"/>
+        <a:font script="Telu" typeface="Gautami"/>
+        <a:font script="Taml" typeface="Latha"/>
+        <a:font script="Syrc" typeface="Estrangelo Edessa"/>
+        <a:font script="Orya" typeface="Kalinga"/>
+        <a:font script="Mlym" typeface="Kartika"/>
+        <a:font script="Laoo" typeface="DokChampa"/>
+        <a:font script="Sinh" typeface="Iskoola Pota"/>
+        <a:font script="Mong" typeface="Mongolian Baiti"/>
+        <a:font script="Viet" typeface="Times New Roman"/>
+        <a:font script="Uigh" typeface="Microsoft Uighur"/>
+        <a:font script="Geor" typeface="Sylfaen"/>
+        <a:font script="Armn" typeface="Arial"/>
+        <a:font script="Bugi" typeface="Leelawadee UI"/>
+        <a:font script="Bopo" typeface="Microsoft JhengHei"/>
+        <a:font script="Java" typeface="Javanese Text"/>
+        <a:font script="Lisu" typeface="Segoe UI"/>
+        <a:font script="Mymr" typeface="Myanmar Text"/>
+        <a:font script="Nkoo" typeface="Ebrima"/>
+        <a:font script="Olck" typeface="Nirmala UI"/>
+        <a:font script="Osma" typeface="Ebrima"/>
+        <a:font script="Phag" typeface="Phagspa"/>
+        <a:font script="Syrn" typeface="Estrangelo Edessa"/>
+        <a:font script="Syrj" typeface="Estrangelo Edessa"/>
+        <a:font script="Syre" typeface="Estrangelo Edessa"/>
+        <a:font script="Sora" typeface="Nirmala UI"/>
+        <a:font script="Tale" typeface="Microsoft Tai Le"/>
+        <a:font script="Talu" typeface="Microsoft New Tai Lue"/>
+        <a:font script="Tfng" typeface="Ebrima"/>
+      </a:majorFont>
+      <a:minorFont>
+        <a:latin typeface="Aptos" panose="02110004020202020204"/>
+        <a:ea typeface=""/>
+        <a:cs typeface=""/>
+        <a:font script="Jpan" typeface="游ゴシック"/>
+        <a:font script="Hang" typeface="맑은 고딕"/>
+        <a:font script="Hans" typeface="等线"/>
+        <a:font script="Hant" typeface="新細明體"/>
+        <a:font script="Arab" typeface="Arial"/>
+        <a:font script="Hebr" typeface="Arial"/>
+        <a:font script="Thai" typeface="Cordia New"/>
+        <a:font script="Ethi" typeface="Nyala"/>
+        <a:font script="Beng" typeface="Vrinda"/>
+        <a:font script="Gujr" typeface="Shruti"/>
+        <a:font script="Khmr" typeface="DaunPenh"/>
+        <a:font script="Knda" typeface="Tunga"/>
+        <a:font script="Guru" typeface="Raavi"/>
+        <a:font script="Cans" typeface="Euphemia"/>
+        <a:font script="Cher" typeface="Plantagenet Cherokee"/>
+        <a:font script="Yiii" typeface="Microsoft Yi Baiti"/>
+        <a:font script="Tibt" typeface="Microsoft Himalaya"/>
+        <a:font script="Thaa" typeface="MV Boli"/>
+        <a:font script="Deva" typeface="Mangal"/>
+        <a:font script="Telu" typeface="Gautami"/>
+        <a:font script="Taml" typeface="Latha"/>
+        <a:font script="Syrc" typeface="Estrangelo Edessa"/>
+        <a:font script="Orya" typeface="Kalinga"/>
+        <a:font script="Mlym" typeface="Kartika"/>
+        <a:font script="Laoo" typeface="DokChampa"/>
+        <a:font script="Sinh" typeface="Iskoola Pota"/>
+        <a:font script="Mong" typeface="Mongolian Baiti"/>
+        <a:font script="Viet" typeface="Arial"/>
+        <a:font script="Uigh" typeface="Microsoft Uighur"/>
+        <a:font script="Geor" typeface="Sylfaen"/>
+        <a:font script="Armn" typeface="Arial"/>
+        <a:font script="Bugi" typeface="Leelawadee UI"/>
+        <a:font script="Bopo" typeface="Microsoft JhengHei"/>
+        <a:font script="Java" typeface="Javanese Text"/>
+        <a:font script="Lisu" typeface="Segoe UI"/>
+        <a:font script="Mymr" typeface="Myanmar Text"/>
+        <a:font script="Nkoo" typeface="Ebrima"/>
+        <a:font script="Olck" typeface="Nirmala UI"/>
+        <a:font script="Osma" typeface="Ebrima"/>
+        <a:font script="Phag" typeface="Phagspa"/>
+        <a:font script="Syrn" typeface="Estrangelo Edessa"/>
+        <a:font script="Syrj" typeface="Estrangelo Edessa"/>
+        <a:font script="Syre" typeface="Estrangelo Edessa"/>
+        <a:font script="Sora" typeface="Nirmala UI"/>
+        <a:font script="Tale" typeface="Microsoft Tai Le"/>
+        <a:font script="Talu" typeface="Microsoft New Tai Lue"/>
+        <a:font script="Tfng" typeface="Ebrima"/>
+      </a:minorFont>
+    </a:fontScheme>
+    <a:fmtScheme name="Office">
+      <a:fillStyleLst>
+        <a:solidFill>
+          <a:schemeClr val="phClr"/>
+        </a:solidFill>
+        <a:gradFill rotWithShape="1">
+          <a:gsLst>
+            <a:gs pos="0">
+              <a:schemeClr val="phClr">
+                <a:lumMod val="110000"/>
+                <a:satMod val="105000"/>
+                <a:tint val="67000"/>
+              </a:schemeClr>
+            </a:gs>
+            <a:gs pos="50000">
+              <a:schemeClr val="phClr">
+                <a:lumMod val="105000"/>
+                <a:satMod val="103000"/>
+                <a:tint val="73000"/>
+              </a:schemeClr>
+            </a:gs>
+            <a:gs pos="100000">
+              <a:schemeClr val="phClr">
+                <a:lumMod val="105000"/>
+                <a:satMod val="109000"/>
+                <a:tint val="81000"/>
+              </a:schemeClr>
+            </a:gs>
+          </a:gsLst>
+          <a:lin ang="5400000" scaled="0"/>
+        </a:gradFill>
+        <a:gradFill rotWithShape="1">
+          <a:gsLst>
+            <a:gs pos="0">
+              <a:schemeClr val="phClr">
+                <a:satMod val="103000"/>
+                <a:lumMod val="102000"/>
+                <a:tint val="94000"/>
+              </a:schemeClr>
+            </a:gs>
+            <a:gs pos="50000">
+              <a:schemeClr val="phClr">
+                <a:satMod val="110000"/>
+                <a:lumMod val="100000"/>
+                <a:shade val="100000"/>
+              </a:schemeClr>
+            </a:gs>
+            <a:gs pos="100000">
+              <a:schemeClr val="phClr">
+                <a:lumMod val="99000"/>
+                <a:satMod val="120000"/>
+                <a:shade val="78000"/>
+              </a:schemeClr>
+            </a:gs>
+          </a:gsLst>
+          <a:lin ang="5400000" scaled="0"/>
+        </a:gradFill>
+      </a:fillStyleLst>
+      <a:lnStyleLst>
+        <a:ln w="12700" cap="flat" cmpd="sng" algn="ctr">
+          <a:solidFill>
+            <a:schemeClr val="phClr"/>
+          </a:solidFill>
+          <a:prstDash val="solid"/>
+          <a:miter lim="800000"/>
+        </a:ln>
+        <a:ln w="19050" cap="flat" cmpd="sng" algn="ctr">
+          <a:solidFill>
+            <a:schemeClr val="phClr"/>
+          </a:solidFill>
+          <a:prstDash val="solid"/>
+          <a:miter lim="800000"/>
+        </a:ln>
+        <a:ln w="25400" cap="flat" cmpd="sng" algn="ctr">
+          <a:solidFill>
+            <a:schemeClr val="phClr"/>
+          </a:solidFill>
+          <a:prstDash val="solid"/>
+          <a:miter lim="800000"/>
+        </a:ln>
+      </a:lnStyleLst>
+      <a:effectStyleLst>
+        <a:effectStyle>
+          <a:effectLst/>
+        </a:effectStyle>
+        <a:effectStyle>
+          <a:effectLst/>
+        </a:effectStyle>
+        <a:effectStyle>
+          <a:effectLst>
+            <a:outerShdw blurRad="57150" dist="19050" dir="5400000" algn="ctr" rotWithShape="0">
+              <a:srgbClr val="000000">
+                <a:alpha val="63000"/>
+              </a:srgbClr>
+            </a:outerShdw>
+          </a:effectLst>
+        </a:effectStyle>
+      </a:effectStyleLst>
+      <a:bgFillStyleLst>
+        <a:solidFill>
+          <a:schemeClr val="phClr"/>
+        </a:solidFill>
+        <a:solidFill>
+          <a:schemeClr val="phClr">
+            <a:tint val="95000"/>
+            <a:satMod val="170000"/>
+          </a:schemeClr>
+        </a:solidFill>
+        <a:gradFill rotWithShape="1">
+          <a:gsLst>
+            <a:gs pos="0">
+              <a:schemeClr val="phClr">
+                <a:tint val="93000"/>
+                <a:satMod val="150000"/>
+                <a:shade val="98000"/>
+                <a:lumMod val="102000"/>
+              </a:schemeClr>
+            </a:gs>
+            <a:gs pos="50000">
+              <a:schemeClr val="phClr">
+                <a:tint val="98000"/>
+                <a:satMod val="130000"/>
+                <a:shade val="90000"/>
+                <a:lumMod val="103000"/>
+              </a:schemeClr>
+            </a:gs>
+            <a:gs pos="100000">
+              <a:schemeClr val="phClr">
+                <a:shade val="63000"/>
+                <a:satMod val="120000"/>
+              </a:schemeClr>
+            </a:gs>
+          </a:gsLst>
+          <a:lin ang="5400000" scaled="0"/>
+        </a:gradFill>
+      </a:bgFillStyleLst>
+    </a:fmtScheme>
+  </a:themeElements>
+  <a:objectDefaults>
+    <a:lnDef>
+      <a:spPr/>
+      <a:bodyPr/>
+      <a:lstStyle/>
+      <a:style>
+        <a:lnRef idx="2">
+          <a:schemeClr val="accent1"/>
+        </a:lnRef>
+        <a:fillRef idx="0">
+          <a:schemeClr val="accent1"/>
+        </a:fillRef>
+        <a:effectRef idx="1">
+          <a:schemeClr val="accent1"/>
+        </a:effectRef>
+        <a:fontRef idx="minor">
+          <a:schemeClr val="tx1"/>
+        </a:fontRef>
+      </a:style>
+    </a:lnDef>
+  </a:objectDefaults>
+  <a:extraClrSchemeLst/>
+  <a:extLst>
+    <a:ext uri="{05A4C25C-085E-4340-85A3-A5531E510DB2}">
+      <thm15:themeFamily xmlns:thm15="http://schemas.microsoft.com/office/thememl/2012/main" name="Office Theme" id="{2E142A2C-CD16-42D6-873A-C26D2A0506FA}" vid="{1BDDFF52-6CD6-40A5-AB3C-68EB2F1E4D0A}"/>
+    </a:ext>
+  </a:extLst>
+</a:theme>
 </file>
</xml_diff>